<commit_message>
feat: rebuild differentiated YatriQ PPTX and interactive HTML monograph presentation
</commit_message>
<xml_diff>
--- a/Smart_Transit_Intelligence_Engineering_Monograph.pptx
+++ b/Smart_Transit_Intelligence_Engineering_Monograph.pptx
@@ -3109,11 +3109,11 @@
             <a:avLst/>
           </a:prstGeom>
           <a:solidFill>
-            <a:srgbClr val="0F172A"/>
+            <a:srgbClr val="0B0F19"/>
           </a:solidFill>
           <a:ln>
             <a:solidFill>
-              <a:srgbClr val="0F172A"/>
+              <a:srgbClr val="0B0F19"/>
             </a:solidFill>
           </a:ln>
         </p:spPr>
@@ -3147,14 +3147,14 @@
         </p:nvSpPr>
         <p:spPr>
           <a:xfrm>
-            <a:off x="457200" y="457200"/>
-            <a:ext cx="11277295" cy="5943600"/>
+            <a:off x="457200" y="411480"/>
+            <a:ext cx="11277295" cy="6035040"/>
           </a:xfrm>
           <a:prstGeom prst="rect">
             <a:avLst/>
           </a:prstGeom>
           <a:solidFill>
-            <a:srgbClr val="0B132B"/>
+            <a:srgbClr val="0E1422"/>
           </a:solidFill>
           <a:ln w="19050">
             <a:solidFill>
@@ -3186,13 +3186,58 @@
       </p:sp>
       <p:sp>
         <p:nvSpPr>
-          <p:cNvPr id="4" name="TextBox 3"/>
+          <p:cNvPr id="4" name="Rectangle 3"/>
+          <p:cNvSpPr/>
+          <p:nvPr/>
+        </p:nvSpPr>
+        <p:spPr>
+          <a:xfrm>
+            <a:off x="594360" y="548640"/>
+            <a:ext cx="11002975" cy="5760720"/>
+          </a:xfrm>
+          <a:prstGeom prst="rect">
+            <a:avLst/>
+          </a:prstGeom>
+          <a:solidFill>
+            <a:srgbClr val="0C111C"/>
+          </a:solidFill>
+          <a:ln w="10160">
+            <a:solidFill>
+              <a:srgbClr val="22304D"/>
+            </a:solidFill>
+          </a:ln>
+        </p:spPr>
+        <p:style>
+          <a:lnRef idx="1">
+            <a:schemeClr val="accent1"/>
+          </a:lnRef>
+          <a:fillRef idx="3">
+            <a:schemeClr val="accent1"/>
+          </a:fillRef>
+          <a:effectRef idx="2">
+            <a:schemeClr val="accent1"/>
+          </a:effectRef>
+          <a:fontRef idx="minor">
+            <a:schemeClr val="lt1"/>
+          </a:fontRef>
+        </p:style>
+        <p:txBody>
+          <a:bodyPr rtlCol="0" anchor="ctr"/>
+          <a:lstStyle/>
+          <a:p>
+            <a:pPr algn="ctr"/>
+          </a:p>
+        </p:txBody>
+      </p:sp>
+      <p:sp>
+        <p:nvSpPr>
+          <p:cNvPr id="5" name="TextBox 4"/>
           <p:cNvSpPr txBox="1"/>
           <p:nvPr/>
         </p:nvSpPr>
         <p:spPr>
           <a:xfrm>
-            <a:off x="1097280" y="1005840"/>
+            <a:off x="1097280" y="960120"/>
             <a:ext cx="9966960" cy="2926080"/>
           </a:xfrm>
           <a:prstGeom prst="rect">
@@ -3207,19 +3252,19 @@
           <a:lstStyle/>
           <a:p>
             <a:pPr>
-              <a:defRPr sz="1200" b="1">
+              <a:defRPr sz="1100" b="1">
                 <a:solidFill>
                   <a:srgbClr val="06B6D4"/>
                 </a:solidFill>
               </a:defRPr>
             </a:pPr>
             <a:r>
-              <a:t>ENGINEERING TREATISE &amp; MONOGRAPH // VOL. 1</a:t>
-            </a:r>
-          </a:p>
-          <a:p>
-            <a:pPr>
-              <a:defRPr sz="3600" b="1">
+              <a:t>AUTONOMOUS TRANSIT MONOGRAPH // VOLUME I // 2026 EDITION</a:t>
+            </a:r>
+          </a:p>
+          <a:p>
+            <a:pPr>
+              <a:defRPr sz="4400" b="1">
                 <a:solidFill>
                   <a:srgbClr val="F8FAFC"/>
                 </a:solidFill>
@@ -3238,7 +3283,7 @@
               </a:defRPr>
             </a:pPr>
             <a:r>
-              <a:t>The Authoritative Transit Truth Layer &amp; 3D Corridor Progression Engine</a:t>
+              <a:t>The Authoritative Transit Truth Layer &amp; 3D Transit Corridor Progression Engine</a:t>
             </a:r>
           </a:p>
           <a:p>
@@ -3250,27 +3295,27 @@
               </a:defRPr>
             </a:pPr>
             <a:r>
-              <a:t>Core Operating Axiom: "Know Your Bus Before It Arrives."</a:t>
-            </a:r>
-          </a:p>
-        </p:txBody>
-      </p:sp>
-      <p:sp>
-        <p:nvSpPr>
-          <p:cNvPr id="5" name="Rounded Rectangle 4"/>
+              <a:t>Core Operating Axiom: "Know Your Bus Before It Arrives"</a:t>
+            </a:r>
+          </a:p>
+        </p:txBody>
+      </p:sp>
+      <p:sp>
+        <p:nvSpPr>
+          <p:cNvPr id="6" name="Rounded Rectangle 5"/>
           <p:cNvSpPr/>
           <p:nvPr/>
         </p:nvSpPr>
         <p:spPr>
           <a:xfrm>
-            <a:off x="1097280" y="3931920"/>
-            <a:ext cx="3108960" cy="2011680"/>
+            <a:off x="1097280" y="3977639"/>
+            <a:ext cx="3154680" cy="2011680"/>
           </a:xfrm>
           <a:prstGeom prst="roundRect">
             <a:avLst/>
           </a:prstGeom>
           <a:solidFill>
-            <a:srgbClr val="1E293B"/>
+            <a:srgbClr val="12192A"/>
           </a:solidFill>
           <a:ln w="15240">
             <a:solidFill>
@@ -3302,14 +3347,14 @@
       </p:sp>
       <p:sp>
         <p:nvSpPr>
-          <p:cNvPr id="6" name="TextBox 5"/>
+          <p:cNvPr id="7" name="TextBox 6"/>
           <p:cNvSpPr txBox="1"/>
           <p:nvPr/>
         </p:nvSpPr>
         <p:spPr>
           <a:xfrm>
-            <a:off x="1280160" y="4069080"/>
-            <a:ext cx="2743200" cy="320040"/>
+            <a:off x="1280160" y="4087367"/>
+            <a:ext cx="2788920" cy="320040"/>
           </a:xfrm>
           <a:prstGeom prst="rect">
             <a:avLst/>
@@ -3323,28 +3368,28 @@
           <a:lstStyle/>
           <a:p>
             <a:pPr>
-              <a:defRPr sz="1050" b="1">
+              <a:defRPr sz="1000" b="1">
                 <a:solidFill>
                   <a:srgbClr val="06B6D4"/>
                 </a:solidFill>
               </a:defRPr>
             </a:pPr>
             <a:r>
-              <a:t>01. ENGINEERING MANDATE</a:t>
-            </a:r>
-          </a:p>
-        </p:txBody>
-      </p:sp>
-      <p:sp>
-        <p:nvSpPr>
-          <p:cNvPr id="7" name="TextBox 6"/>
+              <a:t>01. OPERATIONAL MANDATE</a:t>
+            </a:r>
+          </a:p>
+        </p:txBody>
+      </p:sp>
+      <p:sp>
+        <p:nvSpPr>
+          <p:cNvPr id="8" name="TextBox 7"/>
           <p:cNvSpPr txBox="1"/>
           <p:nvPr/>
         </p:nvSpPr>
         <p:spPr>
           <a:xfrm>
-            <a:off x="1234440" y="4389120"/>
-            <a:ext cx="2834640" cy="1463040"/>
+            <a:off x="1280160" y="4416551"/>
+            <a:ext cx="2788920" cy="1371600"/>
           </a:xfrm>
           <a:prstGeom prst="rect">
             <a:avLst/>
@@ -3358,34 +3403,34 @@
           <a:lstStyle/>
           <a:p>
             <a:pPr>
-              <a:defRPr sz="1000">
+              <a:defRPr sz="950">
                 <a:solidFill>
                   <a:srgbClr val="F8FAFC"/>
                 </a:solidFill>
               </a:defRPr>
             </a:pPr>
             <a:r>
-              <a:t>Eliminating transit uncertainty, 'ghost buses', and crowd anxiety across high-density Indian urban &amp; regional bus networks (DTC, BMTC, BEST, UPSRTC).</a:t>
-            </a:r>
-          </a:p>
-        </p:txBody>
-      </p:sp>
-      <p:sp>
-        <p:nvSpPr>
-          <p:cNvPr id="8" name="Rounded Rectangle 7"/>
+              <a:t>Eradicating commuter crowd anxiety, 'ghost buses', and erratic arrival forecasts across dense Indian metropolitan bus networks (DTC, BMTC, BEST, UPSRTC).</a:t>
+            </a:r>
+          </a:p>
+        </p:txBody>
+      </p:sp>
+      <p:sp>
+        <p:nvSpPr>
+          <p:cNvPr id="9" name="Rounded Rectangle 8"/>
           <p:cNvSpPr/>
           <p:nvPr/>
         </p:nvSpPr>
         <p:spPr>
           <a:xfrm>
-            <a:off x="4526280" y="3931920"/>
-            <a:ext cx="3108960" cy="2011680"/>
+            <a:off x="4572000" y="3977639"/>
+            <a:ext cx="3154680" cy="2011680"/>
           </a:xfrm>
           <a:prstGeom prst="roundRect">
             <a:avLst/>
           </a:prstGeom>
           <a:solidFill>
-            <a:srgbClr val="1E293B"/>
+            <a:srgbClr val="12192A"/>
           </a:solidFill>
           <a:ln w="15240">
             <a:solidFill>
@@ -3417,14 +3462,14 @@
       </p:sp>
       <p:sp>
         <p:nvSpPr>
-          <p:cNvPr id="9" name="TextBox 8"/>
+          <p:cNvPr id="10" name="TextBox 9"/>
           <p:cNvSpPr txBox="1"/>
           <p:nvPr/>
         </p:nvSpPr>
         <p:spPr>
           <a:xfrm>
-            <a:off x="4709160" y="4069080"/>
-            <a:ext cx="2743200" cy="320040"/>
+            <a:off x="4754880" y="4087367"/>
+            <a:ext cx="2788920" cy="320040"/>
           </a:xfrm>
           <a:prstGeom prst="rect">
             <a:avLst/>
@@ -3438,7 +3483,7 @@
           <a:lstStyle/>
           <a:p>
             <a:pPr>
-              <a:defRPr sz="1050" b="1">
+              <a:defRPr sz="1000" b="1">
                 <a:solidFill>
                   <a:srgbClr val="06B6D4"/>
                 </a:solidFill>
@@ -3452,14 +3497,14 @@
       </p:sp>
       <p:sp>
         <p:nvSpPr>
-          <p:cNvPr id="10" name="TextBox 9"/>
+          <p:cNvPr id="11" name="TextBox 10"/>
           <p:cNvSpPr txBox="1"/>
           <p:nvPr/>
         </p:nvSpPr>
         <p:spPr>
           <a:xfrm>
-            <a:off x="4663440" y="4389120"/>
-            <a:ext cx="2834640" cy="1463040"/>
+            <a:off x="4754880" y="4416551"/>
+            <a:ext cx="2788920" cy="1371600"/>
           </a:xfrm>
           <a:prstGeom prst="rect">
             <a:avLst/>
@@ -3473,34 +3518,34 @@
           <a:lstStyle/>
           <a:p>
             <a:pPr>
-              <a:defRPr sz="1000">
+              <a:defRPr sz="950">
                 <a:solidFill>
                   <a:srgbClr val="F8FAFC"/>
                 </a:solidFill>
               </a:defRPr>
             </a:pPr>
             <a:r>
-              <a:t>TRACK (Kalman/Map-Match) -&gt; ESTIMATE (Edge-AI OpenCV Density) -&gt; PREDICT (Gradient Boosted ETAs) -&gt; INFORM (Authoritative Decision UX).</a:t>
-            </a:r>
-          </a:p>
-        </p:txBody>
-      </p:sp>
-      <p:sp>
-        <p:nvSpPr>
-          <p:cNvPr id="11" name="Rounded Rectangle 10"/>
+              <a:t>TRACK (Kalman &amp; Map Matching) -&gt; ESTIMATE (Onboard Edge-AI Computer Vision) -&gt; PREDICT (Gradient Boosted Regressors) -&gt; INFORM (Calm Commute UX).</a:t>
+            </a:r>
+          </a:p>
+        </p:txBody>
+      </p:sp>
+      <p:sp>
+        <p:nvSpPr>
+          <p:cNvPr id="12" name="Rounded Rectangle 11"/>
           <p:cNvSpPr/>
           <p:nvPr/>
         </p:nvSpPr>
         <p:spPr>
           <a:xfrm>
-            <a:off x="7955280" y="3931920"/>
-            <a:ext cx="3108960" cy="2011680"/>
+            <a:off x="8046720" y="3977639"/>
+            <a:ext cx="3154680" cy="2011680"/>
           </a:xfrm>
           <a:prstGeom prst="roundRect">
             <a:avLst/>
           </a:prstGeom>
           <a:solidFill>
-            <a:srgbClr val="1E293B"/>
+            <a:srgbClr val="12192A"/>
           </a:solidFill>
           <a:ln w="15240">
             <a:solidFill>
@@ -3532,14 +3577,14 @@
       </p:sp>
       <p:sp>
         <p:nvSpPr>
-          <p:cNvPr id="12" name="TextBox 11"/>
+          <p:cNvPr id="13" name="TextBox 12"/>
           <p:cNvSpPr txBox="1"/>
           <p:nvPr/>
         </p:nvSpPr>
         <p:spPr>
           <a:xfrm>
-            <a:off x="8138160" y="4069080"/>
-            <a:ext cx="2743200" cy="320040"/>
+            <a:off x="8229600" y="4087367"/>
+            <a:ext cx="2788920" cy="320040"/>
           </a:xfrm>
           <a:prstGeom prst="rect">
             <a:avLst/>
@@ -3553,7 +3598,7 @@
           <a:lstStyle/>
           <a:p>
             <a:pPr>
-              <a:defRPr sz="1050" b="1">
+              <a:defRPr sz="1000" b="1">
                 <a:solidFill>
                   <a:srgbClr val="06B6D4"/>
                 </a:solidFill>
@@ -3567,14 +3612,14 @@
       </p:sp>
       <p:sp>
         <p:nvSpPr>
-          <p:cNvPr id="13" name="TextBox 12"/>
+          <p:cNvPr id="14" name="TextBox 13"/>
           <p:cNvSpPr txBox="1"/>
           <p:nvPr/>
         </p:nvSpPr>
         <p:spPr>
           <a:xfrm>
-            <a:off x="8092440" y="4389120"/>
-            <a:ext cx="2834640" cy="1463040"/>
+            <a:off x="8229600" y="4416551"/>
+            <a:ext cx="2788920" cy="1371600"/>
           </a:xfrm>
           <a:prstGeom prst="rect">
             <a:avLst/>
@@ -3588,14 +3633,14 @@
           <a:lstStyle/>
           <a:p>
             <a:pPr>
-              <a:defRPr sz="1000">
+              <a:defRPr sz="950">
                 <a:solidFill>
                   <a:srgbClr val="F8FAFC"/>
                 </a:solidFill>
               </a:defRPr>
             </a:pPr>
             <a:r>
-              <a:t>Anand Vihar &lt;-&gt; Modipuram Corridor (58.2 km, 21 Rapid Transit Stations, Full Monotonic Simulation &amp; Real-World Geometries).</a:t>
+              <a:t>Anand Vihar &lt;-&gt; Modipuram Rapid Transit Corridor (~58.2 km, 21 Verified Rapid Transit Stations, Full Monotonic Simulation &amp; Real-World Geometries).</a:t>
             </a:r>
           </a:p>
         </p:txBody>
@@ -3633,11 +3678,11 @@
             <a:avLst/>
           </a:prstGeom>
           <a:solidFill>
-            <a:srgbClr val="0F172A"/>
+            <a:srgbClr val="0B0F19"/>
           </a:solidFill>
           <a:ln>
             <a:solidFill>
-              <a:srgbClr val="0F172A"/>
+              <a:srgbClr val="0B0F19"/>
             </a:solidFill>
           </a:ln>
         </p:spPr>
@@ -3672,7 +3717,7 @@
         <p:spPr>
           <a:xfrm>
             <a:off x="731520" y="365760"/>
-            <a:ext cx="10728655" cy="822960"/>
+            <a:ext cx="10728655" cy="868680"/>
           </a:xfrm>
           <a:prstGeom prst="rect">
             <a:avLst/>
@@ -3693,12 +3738,12 @@
               </a:defRPr>
             </a:pPr>
             <a:r>
-              <a:t>CHAPTER 01 // TECHNICAL MONOGRAPH // TRANSIT INTELLIGENCE SYSTEMS</a:t>
-            </a:r>
-          </a:p>
-          <a:p>
-            <a:pPr>
-              <a:defRPr sz="2000" b="1">
+              <a:t>CHAPTER I // TECHNICAL MONOGRAPH // YATRIQ TRANSIT INTELLIGENCE</a:t>
+            </a:r>
+          </a:p>
+          <a:p>
+            <a:pPr>
+              <a:defRPr sz="2100" b="1">
                 <a:solidFill>
                   <a:srgbClr val="F8FAFC"/>
                 </a:solidFill>
@@ -3717,7 +3762,7 @@
               </a:defRPr>
             </a:pPr>
             <a:r>
-              <a:t>Why Traditional Fleet Tracking Fails and the TRACK -&gt; ESTIMATE -&gt; PREDICT -&gt; INFORM Pipeline</a:t>
+              <a:t>Why Legacy Fleet Trackers Fail and the TRACK -&gt; ESTIMATE -&gt; PREDICT -&gt; INFORM Solution</a:t>
             </a:r>
           </a:p>
         </p:txBody>
@@ -3730,8 +3775,8 @@
         </p:nvSpPr>
         <p:spPr>
           <a:xfrm>
-            <a:off x="10058400" y="365760"/>
-            <a:ext cx="1371600" cy="457200"/>
+            <a:off x="9875520" y="365760"/>
+            <a:ext cx="1584655" cy="365760"/>
           </a:xfrm>
           <a:prstGeom prst="rect">
             <a:avLst/>
@@ -3745,7 +3790,7 @@
           <a:lstStyle/>
           <a:p>
             <a:pPr algn="r">
-              <a:defRPr sz="1000" b="1">
+              <a:defRPr sz="1050" b="1">
                 <a:solidFill>
                   <a:srgbClr val="F59E0B"/>
                 </a:solidFill>
@@ -3765,18 +3810,18 @@
         </p:nvSpPr>
         <p:spPr>
           <a:xfrm>
-            <a:off x="731520" y="1234440"/>
+            <a:off x="731520" y="1280160"/>
             <a:ext cx="10728655" cy="18288"/>
           </a:xfrm>
           <a:prstGeom prst="rect">
             <a:avLst/>
           </a:prstGeom>
           <a:solidFill>
-            <a:srgbClr val="334155"/>
+            <a:srgbClr val="22304D"/>
           </a:solidFill>
           <a:ln>
             <a:solidFill>
-              <a:srgbClr val="334155"/>
+              <a:srgbClr val="22304D"/>
             </a:solidFill>
           </a:ln>
         </p:spPr>
@@ -3810,18 +3855,18 @@
         </p:nvSpPr>
         <p:spPr>
           <a:xfrm>
-            <a:off x="731520" y="1463040"/>
-            <a:ext cx="5120640" cy="4846320"/>
+            <a:off x="731520" y="1508760"/>
+            <a:ext cx="5120640" cy="4800600"/>
           </a:xfrm>
           <a:prstGeom prst="roundRect">
             <a:avLst/>
           </a:prstGeom>
           <a:solidFill>
-            <a:srgbClr val="1E293B"/>
+            <a:srgbClr val="12192A"/>
           </a:solidFill>
           <a:ln w="15240">
             <a:solidFill>
-              <a:srgbClr val="334155"/>
+              <a:srgbClr val="22304D"/>
             </a:solidFill>
           </a:ln>
         </p:spPr>
@@ -3855,7 +3900,7 @@
         </p:nvSpPr>
         <p:spPr>
           <a:xfrm>
-            <a:off x="914400" y="1600200"/>
+            <a:off x="914400" y="1618488"/>
             <a:ext cx="4754880" cy="320040"/>
           </a:xfrm>
           <a:prstGeom prst="rect">
@@ -3870,14 +3915,14 @@
           <a:lstStyle/>
           <a:p>
             <a:pPr>
-              <a:defRPr sz="1050" b="1">
+              <a:defRPr sz="1000" b="1">
                 <a:solidFill>
                   <a:srgbClr val="06B6D4"/>
                 </a:solidFill>
               </a:defRPr>
             </a:pPr>
             <a:r>
-              <a:t>DEFICIENCIES IN LEGACY TRANSIT TRACKING SYSTEMS</a:t>
+              <a:t>01. FOUR FAILURE MODES OF LEGACY FLEET TRACKING</a:t>
             </a:r>
           </a:p>
         </p:txBody>
@@ -3890,7 +3935,7 @@
         </p:nvSpPr>
         <p:spPr>
           <a:xfrm>
-            <a:off x="914400" y="1920240"/>
+            <a:off x="914400" y="1965960"/>
             <a:ext cx="4754880" cy="4206240"/>
           </a:xfrm>
           <a:prstGeom prst="rect">
@@ -3905,65 +3950,65 @@
           <a:lstStyle/>
           <a:p>
             <a:pPr>
-              <a:defRPr sz="1100" b="1">
+              <a:defRPr sz="1050" b="1">
                 <a:solidFill>
                   <a:srgbClr val="F59E0B"/>
                 </a:solidFill>
               </a:defRPr>
             </a:pPr>
             <a:r>
-              <a:t>1. Ghost Buses &amp; ETA Mirage</a:t>
-            </a:r>
-          </a:p>
-          <a:p>
-            <a:pPr>
-              <a:defRPr sz="950">
+              <a:t>1. Ghost Buses &amp; Static ETA Collapse</a:t>
+            </a:r>
+          </a:p>
+          <a:p>
+            <a:pPr>
+              <a:defRPr sz="900">
                 <a:solidFill>
                   <a:srgbClr val="94A3B8"/>
                 </a:solidFill>
               </a:defRPr>
             </a:pPr>
             <a:r>
-              <a:t>Static schedule interpolations fail in mixed Indian traffic. Commuters wait for buses that are already stranded, deadheading, or cancelled.</a:t>
-            </a:r>
-          </a:p>
-          <a:p>
-            <a:pPr>
-              <a:defRPr sz="400"/>
-            </a:pPr>
-          </a:p>
-          <a:p>
-            <a:pPr>
-              <a:defRPr sz="1100" b="1">
+              <a:t>Timetable interpolations fail in mixed traffic. Commuters wait for stranded, cancelled, or deadheading vehicles that never arrive.</a:t>
+            </a:r>
+          </a:p>
+          <a:p>
+            <a:pPr>
+              <a:defRPr sz="300"/>
+            </a:pPr>
+          </a:p>
+          <a:p>
+            <a:pPr>
+              <a:defRPr sz="1050" b="1">
                 <a:solidFill>
                   <a:srgbClr val="F59E0B"/>
                 </a:solidFill>
               </a:defRPr>
             </a:pPr>
             <a:r>
-              <a:t>2. Commuter Crowd Anxiety</a:t>
-            </a:r>
-          </a:p>
-          <a:p>
-            <a:pPr>
-              <a:defRPr sz="950">
+              <a:t>2. Commuter Crowd Anxiety &amp; Door Mobbing</a:t>
+            </a:r>
+          </a:p>
+          <a:p>
+            <a:pPr>
+              <a:defRPr sz="900">
                 <a:solidFill>
                   <a:srgbClr val="94A3B8"/>
                 </a:solidFill>
               </a:defRPr>
             </a:pPr>
             <a:r>
-              <a:t>Passengers face zero prior visibility into onboard crowding. Overcrowded buses are mobbed while near-empty trailing buses run unnoticed.</a:t>
-            </a:r>
-          </a:p>
-          <a:p>
-            <a:pPr>
-              <a:defRPr sz="400"/>
-            </a:pPr>
-          </a:p>
-          <a:p>
-            <a:pPr>
-              <a:defRPr sz="1100" b="1">
+              <a:t>Zero prior visibility into onboard passenger density causes desperate boarding stampedes while trailing, near-empty feeder buses pass unnoticed.</a:t>
+            </a:r>
+          </a:p>
+          <a:p>
+            <a:pPr>
+              <a:defRPr sz="300"/>
+            </a:pPr>
+          </a:p>
+          <a:p>
+            <a:pPr>
+              <a:defRPr sz="1050" b="1">
                 <a:solidFill>
                   <a:srgbClr val="F59E0B"/>
                 </a:solidFill>
@@ -3975,43 +4020,43 @@
           </a:p>
           <a:p>
             <a:pPr>
-              <a:defRPr sz="950">
+              <a:defRPr sz="900">
                 <a:solidFill>
                   <a:srgbClr val="94A3B8"/>
                 </a:solidFill>
               </a:defRPr>
             </a:pPr>
             <a:r>
-              <a:t>Conventional apps present raw ML predictions as real-time GPS fixes without source transparency, timestamps, or confidence metrics.</a:t>
-            </a:r>
-          </a:p>
-          <a:p>
-            <a:pPr>
-              <a:defRPr sz="400"/>
-            </a:pPr>
-          </a:p>
-          <a:p>
-            <a:pPr>
-              <a:defRPr sz="1100" b="1">
+              <a:t>Conventional apps present raw ML predictions as live GPS fixes without disclosing source authenticity, confidence score, or observation age.</a:t>
+            </a:r>
+          </a:p>
+          <a:p>
+            <a:pPr>
+              <a:defRPr sz="300"/>
+            </a:pPr>
+          </a:p>
+          <a:p>
+            <a:pPr>
+              <a:defRPr sz="1050" b="1">
                 <a:solidFill>
                   <a:srgbClr val="F59E0B"/>
                 </a:solidFill>
               </a:defRPr>
             </a:pPr>
             <a:r>
-              <a:t>4. Cellular Dead-Zone Dropouts</a:t>
-            </a:r>
-          </a:p>
-          <a:p>
-            <a:pPr>
-              <a:defRPr sz="950">
+              <a:t>4. Cellular Dead-Zone Freezes</a:t>
+            </a:r>
+          </a:p>
+          <a:p>
+            <a:pPr>
+              <a:defRPr sz="900">
                 <a:solidFill>
                   <a:srgbClr val="94A3B8"/>
                 </a:solidFill>
               </a:defRPr>
             </a:pPr>
             <a:r>
-              <a:t>Arterial highway underpasses and rural sections trigger 4G/5G signal drops, freezing vehicle radars and dropping commuter updates.</a:t>
+              <a:t>Highway flyovers and underpasses create 4G/5G dropouts, dropping network polling, freezing vehicle blips, and failing commuter updates.</a:t>
             </a:r>
           </a:p>
         </p:txBody>
@@ -4024,14 +4069,14 @@
         </p:nvSpPr>
         <p:spPr>
           <a:xfrm>
-            <a:off x="6126480" y="1463040"/>
-            <a:ext cx="5303520" cy="4846320"/>
+            <a:off x="6217920" y="1508760"/>
+            <a:ext cx="5242255" cy="4800600"/>
           </a:xfrm>
           <a:prstGeom prst="roundRect">
             <a:avLst/>
           </a:prstGeom>
           <a:solidFill>
-            <a:srgbClr val="1E293B"/>
+            <a:srgbClr val="12192A"/>
           </a:solidFill>
           <a:ln w="15240">
             <a:solidFill>
@@ -4069,8 +4114,8 @@
         </p:nvSpPr>
         <p:spPr>
           <a:xfrm>
-            <a:off x="6309360" y="1600200"/>
-            <a:ext cx="4937760" cy="320040"/>
+            <a:off x="6400800" y="1618488"/>
+            <a:ext cx="4876495" cy="320040"/>
           </a:xfrm>
           <a:prstGeom prst="rect">
             <a:avLst/>
@@ -4084,14 +4129,14 @@
           <a:lstStyle/>
           <a:p>
             <a:pPr>
-              <a:defRPr sz="1050" b="1">
+              <a:defRPr sz="1000" b="1">
                 <a:solidFill>
                   <a:srgbClr val="06B6D4"/>
                 </a:solidFill>
               </a:defRPr>
             </a:pPr>
             <a:r>
-              <a:t>THE 4-STAGE REMEDIATION PIPELINE</a:t>
+              <a:t>02. THE 4-STAGE REMEDIATION ENGINE</a:t>
             </a:r>
           </a:p>
         </p:txBody>
@@ -4104,8 +4149,8 @@
         </p:nvSpPr>
         <p:spPr>
           <a:xfrm>
-            <a:off x="6309360" y="1920240"/>
-            <a:ext cx="4937760" cy="4206240"/>
+            <a:off x="6400800" y="1965960"/>
+            <a:ext cx="4876495" cy="4206240"/>
           </a:xfrm>
           <a:prstGeom prst="rect">
             <a:avLst/>
@@ -4119,65 +4164,65 @@
           <a:lstStyle/>
           <a:p>
             <a:pPr>
-              <a:defRPr sz="1100" b="1">
+              <a:defRPr sz="1050" b="1">
                 <a:solidFill>
                   <a:srgbClr val="06B6D4"/>
                 </a:solidFill>
               </a:defRPr>
             </a:pPr>
             <a:r>
-              <a:t>STAGE 1: TRACK (Geospatial Position)</a:t>
-            </a:r>
-          </a:p>
-          <a:p>
-            <a:pPr>
-              <a:defRPr sz="950">
+              <a:t>STAGE 1: TRACK (Geospatial Kinematics)</a:t>
+            </a:r>
+          </a:p>
+          <a:p>
+            <a:pPr>
+              <a:defRPr sz="900">
                 <a:solidFill>
                   <a:srgbClr val="F8FAFC"/>
                 </a:solidFill>
               </a:defRPr>
             </a:pPr>
             <a:r>
-              <a:t>Continuous high-precision GPS telemetry. Rejects stale coordinates (&gt;60s) and out-of-order pings. Snaps coordinates within 55m cross-track error bounds.</a:t>
-            </a:r>
-          </a:p>
-          <a:p>
-            <a:pPr>
-              <a:defRPr sz="400"/>
-            </a:pPr>
-          </a:p>
-          <a:p>
-            <a:pPr>
-              <a:defRPr sz="1100" b="1">
+              <a:t>Continuous GPS telemetry ingestion. Enforces monotonic ordering, tolerates jitter via 55m cross-track snapping, and rejects stale/out-of-order pings.</a:t>
+            </a:r>
+          </a:p>
+          <a:p>
+            <a:pPr>
+              <a:defRPr sz="300"/>
+            </a:pPr>
+          </a:p>
+          <a:p>
+            <a:pPr>
+              <a:defRPr sz="1050" b="1">
                 <a:solidFill>
                   <a:srgbClr val="06B6D4"/>
                 </a:solidFill>
               </a:defRPr>
             </a:pPr>
             <a:r>
-              <a:t>STAGE 2: ESTIMATE (Onboard Privacy-Preserving Vision)</a:t>
-            </a:r>
-          </a:p>
-          <a:p>
-            <a:pPr>
-              <a:defRPr sz="950">
+              <a:t>STAGE 2: ESTIMATE (Onboard Edge Computer Vision)</a:t>
+            </a:r>
+          </a:p>
+          <a:p>
+            <a:pPr>
+              <a:defRPr sz="900">
                 <a:solidFill>
                   <a:srgbClr val="F8FAFC"/>
                 </a:solidFill>
               </a:defRPr>
             </a:pPr>
             <a:r>
-              <a:t>Edge-AI computer vision runs directly on bus cabin hardware. Estimates occupancy via pixel density &amp; 3-stage temporal hysteresis without uploading faces or video.</a:t>
-            </a:r>
-          </a:p>
-          <a:p>
-            <a:pPr>
-              <a:defRPr sz="400"/>
-            </a:pPr>
-          </a:p>
-          <a:p>
-            <a:pPr>
-              <a:defRPr sz="1100" b="1">
+              <a:t>Runs locally on vehicle hardware (Jetson / Pi 4). Estimates passenger density via pixel contours &amp; 3-stage temporal hysteresis without uploading faces or video.</a:t>
+            </a:r>
+          </a:p>
+          <a:p>
+            <a:pPr>
+              <a:defRPr sz="300"/>
+            </a:pPr>
+          </a:p>
+          <a:p>
+            <a:pPr>
+              <a:defRPr sz="1050" b="1">
                 <a:solidFill>
                   <a:srgbClr val="06B6D4"/>
                 </a:solidFill>
@@ -4189,43 +4234,43 @@
           </a:p>
           <a:p>
             <a:pPr>
-              <a:defRPr sz="950">
+              <a:defRPr sz="900">
                 <a:solidFill>
                   <a:srgbClr val="F8FAFC"/>
                 </a:solidFill>
               </a:defRPr>
             </a:pPr>
             <a:r>
-              <a:t>Forecasts dynamic segment travel times, dwell durations, and downstream crowd changes based on corridor traffic patterns and temporal baselines.</a:t>
-            </a:r>
-          </a:p>
-          <a:p>
-            <a:pPr>
-              <a:defRPr sz="400"/>
-            </a:pPr>
-          </a:p>
-          <a:p>
-            <a:pPr>
-              <a:defRPr sz="1100" b="1">
+              <a:t>Forecasts dynamic segment travel times, dwell times, and downstream passenger boarding deltas using historical corridor traffic patterns.</a:t>
+            </a:r>
+          </a:p>
+          <a:p>
+            <a:pPr>
+              <a:defRPr sz="300"/>
+            </a:pPr>
+          </a:p>
+          <a:p>
+            <a:pPr>
+              <a:defRPr sz="1050" b="1">
                 <a:solidFill>
                   <a:srgbClr val="06B6D4"/>
                 </a:solidFill>
               </a:defRPr>
             </a:pPr>
             <a:r>
-              <a:t>STAGE 4: INFORM (Actionable Commuter Decision UX)</a:t>
-            </a:r>
-          </a:p>
-          <a:p>
-            <a:pPr>
-              <a:defRPr sz="950">
+              <a:t>STAGE 4: INFORM (Actionable Calm Commute UX)</a:t>
+            </a:r>
+          </a:p>
+          <a:p>
+            <a:pPr>
+              <a:defRPr sz="900">
                 <a:solidFill>
                   <a:srgbClr val="F8FAFC"/>
                 </a:solidFill>
               </a:defRPr>
             </a:pPr>
             <a:r>
-              <a:t>Presents clean decision cards: FASTEST vs. MOST COMFORTABLE with transparent Data Provenance (LIVE CCTV, PREDICTED, HISTORICAL).</a:t>
+              <a:t>Presents commuters with clear FASTEST vs MOST COMFORTABLE decision cards, humanized crowd indicators, and transparent Data Provenance badges.</a:t>
             </a:r>
           </a:p>
         </p:txBody>
@@ -4263,11 +4308,11 @@
             <a:avLst/>
           </a:prstGeom>
           <a:solidFill>
-            <a:srgbClr val="0F172A"/>
+            <a:srgbClr val="0B0F19"/>
           </a:solidFill>
           <a:ln>
             <a:solidFill>
-              <a:srgbClr val="0F172A"/>
+              <a:srgbClr val="0B0F19"/>
             </a:solidFill>
           </a:ln>
         </p:spPr>
@@ -4302,7 +4347,7 @@
         <p:spPr>
           <a:xfrm>
             <a:off x="731520" y="365760"/>
-            <a:ext cx="10728655" cy="822960"/>
+            <a:ext cx="10728655" cy="868680"/>
           </a:xfrm>
           <a:prstGeom prst="rect">
             <a:avLst/>
@@ -4323,12 +4368,12 @@
               </a:defRPr>
             </a:pPr>
             <a:r>
-              <a:t>CHAPTER 02 // TECHNICAL MONOGRAPH // TRANSIT INTELLIGENCE SYSTEMS</a:t>
-            </a:r>
-          </a:p>
-          <a:p>
-            <a:pPr>
-              <a:defRPr sz="2000" b="1">
+              <a:t>CHAPTER II // TECHNICAL MONOGRAPH // YATRIQ TRANSIT INTELLIGENCE</a:t>
+            </a:r>
+          </a:p>
+          <a:p>
+            <a:pPr>
+              <a:defRPr sz="2100" b="1">
                 <a:solidFill>
                   <a:srgbClr val="F8FAFC"/>
                 </a:solidFill>
@@ -4360,8 +4405,8 @@
         </p:nvSpPr>
         <p:spPr>
           <a:xfrm>
-            <a:off x="10058400" y="365760"/>
-            <a:ext cx="1371600" cy="457200"/>
+            <a:off x="9875520" y="365760"/>
+            <a:ext cx="1584655" cy="365760"/>
           </a:xfrm>
           <a:prstGeom prst="rect">
             <a:avLst/>
@@ -4375,7 +4420,7 @@
           <a:lstStyle/>
           <a:p>
             <a:pPr algn="r">
-              <a:defRPr sz="1000" b="1">
+              <a:defRPr sz="1050" b="1">
                 <a:solidFill>
                   <a:srgbClr val="F59E0B"/>
                 </a:solidFill>
@@ -4395,18 +4440,18 @@
         </p:nvSpPr>
         <p:spPr>
           <a:xfrm>
-            <a:off x="731520" y="1234440"/>
+            <a:off x="731520" y="1280160"/>
             <a:ext cx="10728655" cy="18288"/>
           </a:xfrm>
           <a:prstGeom prst="rect">
             <a:avLst/>
           </a:prstGeom>
           <a:solidFill>
-            <a:srgbClr val="334155"/>
+            <a:srgbClr val="22304D"/>
           </a:solidFill>
           <a:ln>
             <a:solidFill>
-              <a:srgbClr val="334155"/>
+              <a:srgbClr val="22304D"/>
             </a:solidFill>
           </a:ln>
         </p:spPr>
@@ -4440,14 +4485,14 @@
         </p:nvSpPr>
         <p:spPr>
           <a:xfrm>
-            <a:off x="731520" y="1463040"/>
+            <a:off x="731520" y="1508760"/>
             <a:ext cx="10728655" cy="1371600"/>
           </a:xfrm>
           <a:prstGeom prst="roundRect">
             <a:avLst/>
           </a:prstGeom>
           <a:solidFill>
-            <a:srgbClr val="1E293B"/>
+            <a:srgbClr val="12192A"/>
           </a:solidFill>
           <a:ln w="15240">
             <a:solidFill>
@@ -4485,7 +4530,7 @@
         </p:nvSpPr>
         <p:spPr>
           <a:xfrm>
-            <a:off x="914400" y="1600200"/>
+            <a:off x="914400" y="1618488"/>
             <a:ext cx="10362895" cy="320040"/>
           </a:xfrm>
           <a:prstGeom prst="rect">
@@ -4500,14 +4545,14 @@
           <a:lstStyle/>
           <a:p>
             <a:pPr>
-              <a:defRPr sz="1050" b="1">
+              <a:defRPr sz="1000" b="1">
                 <a:solidFill>
                   <a:srgbClr val="06B6D4"/>
                 </a:solidFill>
               </a:defRPr>
             </a:pPr>
             <a:r>
-              <a:t>CORE MATHEMATICAL INVARIANTS OF THE TRUTH ENGINE</a:t>
+              <a:t>MATHEMATICAL INVARIANTS OF THE TRUTH ENGINE</a:t>
             </a:r>
           </a:p>
         </p:txBody>
@@ -4521,7 +4566,7 @@
         <p:spPr>
           <a:xfrm>
             <a:off x="914400" y="1874519"/>
-            <a:ext cx="10332720" cy="822960"/>
+            <a:ext cx="10332720" cy="914400"/>
           </a:xfrm>
           <a:prstGeom prst="rect">
             <a:avLst/>
@@ -4542,15 +4587,15 @@
               </a:defRPr>
             </a:pPr>
             <a:r>
-              <a:t>INVARIANT I: Monotonic Time (t_device^(k) &gt; t_device^(k-1)) - Out-of-order delayed packets are stored for audit but NEVER overwrite active state.</a:t>
+              <a:t>INVARIANT I: Monotonic Device Time (t_device^(k) &gt; t_device^(k-1)) -&gt; Replayed out-of-order packets from blackspots are safely archived but NEVER overwrite live state.</a:t>
             </a:r>
             <a:br/>
             <a:r>
-              <a:t>INVARIANT II: Sensor Primacy - Real-time physical observation ALWAYS supercedes ML inference; ML predictions never overwrite live telemetry.</a:t>
+              <a:t>INVARIANT II: Sensor Primacy Rule -&gt; Fresh physical observations (&lt;30s) always take precedence over ML inferences; predictions never overwrite sensors.</a:t>
             </a:r>
             <a:br/>
             <a:r>
-              <a:t>INVARIANT III: Idempotent Deduplication - Ingestion uses composite UUIDs &amp; monotonic cache barriers to prevent replay corruption.</a:t>
+              <a:t>INVARIANT III: Idempotent Deduplication -&gt; Telemetry ingestion applies composite hash keys {device_id, monotonic_seq, t_device} to eliminate duplicate packets.</a:t>
             </a:r>
           </a:p>
         </p:txBody>
@@ -4563,14 +4608,14 @@
         </p:nvSpPr>
         <p:spPr>
           <a:xfrm>
-            <a:off x="731520" y="3017520"/>
-            <a:ext cx="5212080" cy="3291840"/>
+            <a:off x="731520" y="3063240"/>
+            <a:ext cx="5212080" cy="3246120"/>
           </a:xfrm>
           <a:prstGeom prst="roundRect">
             <a:avLst/>
           </a:prstGeom>
           <a:solidFill>
-            <a:srgbClr val="1E293B"/>
+            <a:srgbClr val="12192A"/>
           </a:solidFill>
           <a:ln w="15240">
             <a:solidFill>
@@ -4608,7 +4653,7 @@
         </p:nvSpPr>
         <p:spPr>
           <a:xfrm>
-            <a:off x="914400" y="3154680"/>
+            <a:off x="914400" y="3172968"/>
             <a:ext cx="4846320" cy="320040"/>
           </a:xfrm>
           <a:prstGeom prst="rect">
@@ -4623,7 +4668,7 @@
           <a:lstStyle/>
           <a:p>
             <a:pPr>
-              <a:defRPr sz="1050" b="1">
+              <a:defRPr sz="1000" b="1">
                 <a:solidFill>
                   <a:srgbClr val="06B6D4"/>
                 </a:solidFill>
@@ -4658,7 +4703,7 @@
           <a:lstStyle/>
           <a:p>
             <a:pPr>
-              <a:defRPr sz="1000" b="1">
+              <a:defRPr sz="950" b="1">
                 <a:solidFill>
                   <a:srgbClr val="10B981"/>
                 </a:solidFill>
@@ -4677,12 +4722,12 @@
               </a:defRPr>
             </a:pPr>
             <a:r>
-              <a:t>State: LIVE | Confidence: 95-100% | Source: Direct ITS hardware</a:t>
-            </a:r>
-          </a:p>
-          <a:p>
-            <a:pPr>
-              <a:defRPr sz="1000" b="1">
+              <a:t>State: LIVE | Confidence: 95-100% | Source: Direct transit authority ITS feed</a:t>
+            </a:r>
+          </a:p>
+          <a:p>
+            <a:pPr>
+              <a:defRPr sz="950" b="1">
                 <a:solidFill>
                   <a:srgbClr val="10B981"/>
                 </a:solidFill>
@@ -4701,12 +4746,12 @@
               </a:defRPr>
             </a:pPr>
             <a:r>
-              <a:t>State: LIVE | Confidence: 85-95% | Source: Onboard IoT telemetry</a:t>
-            </a:r>
-          </a:p>
-          <a:p>
-            <a:pPr>
-              <a:defRPr sz="1000" b="1">
+              <a:t>State: LIVE | Confidence: 85-95% | Source: Onboard IoT telemetry unit</a:t>
+            </a:r>
+          </a:p>
+          <a:p>
+            <a:pPr>
+              <a:defRPr sz="950" b="1">
                 <a:solidFill>
                   <a:srgbClr val="10B981"/>
                 </a:solidFill>
@@ -4725,12 +4770,12 @@
               </a:defRPr>
             </a:pPr>
             <a:r>
-              <a:t>State: OBSERVED | Confidence: 70-85% | Source: Cached telemetry</a:t>
-            </a:r>
-          </a:p>
-          <a:p>
-            <a:pPr>
-              <a:defRPr sz="1000" b="1">
+              <a:t>State: OBSERVED | Confidence: 70-85% | Source: Cached recent position</a:t>
+            </a:r>
+          </a:p>
+          <a:p>
+            <a:pPr>
+              <a:defRPr sz="950" b="1">
                 <a:solidFill>
                   <a:srgbClr val="10B981"/>
                 </a:solidFill>
@@ -4749,19 +4794,19 @@
               </a:defRPr>
             </a:pPr>
             <a:r>
-              <a:t>State: STALE | Confidence: 40-60% | Provenance flag: Stale degraded</a:t>
-            </a:r>
-          </a:p>
-          <a:p>
-            <a:pPr>
-              <a:defRPr sz="1000" b="1">
+              <a:t>State: STALE | Flagged clearly on UI with reassuring 'Updating Soon' notice</a:t>
+            </a:r>
+          </a:p>
+          <a:p>
+            <a:pPr>
+              <a:defRPr sz="950" b="1">
                 <a:solidFill>
                   <a:srgbClr val="10B981"/>
                 </a:solidFill>
               </a:defRPr>
             </a:pPr>
             <a:r>
-              <a:t>Priority 5: Fallback / Deadhead (&gt;300s)</a:t>
+              <a:t>Priority 5: Deadhead / Disconnected (&gt;300s)</a:t>
             </a:r>
           </a:p>
           <a:p>
@@ -4773,7 +4818,7 @@
               </a:defRPr>
             </a:pPr>
             <a:r>
-              <a:t>State: UNAVAILABLE | UI: Grayed radar blip with alert warning</a:t>
+              <a:t>State: UNAVAILABLE | Vehicle marked unavailable to avoid ghost trips</a:t>
             </a:r>
           </a:p>
         </p:txBody>
@@ -4786,14 +4831,14 @@
         </p:nvSpPr>
         <p:spPr>
           <a:xfrm>
-            <a:off x="6217920" y="3017520"/>
-            <a:ext cx="5242255" cy="3291840"/>
+            <a:off x="6217920" y="3063240"/>
+            <a:ext cx="5242255" cy="3246120"/>
           </a:xfrm>
           <a:prstGeom prst="roundRect">
             <a:avLst/>
           </a:prstGeom>
           <a:solidFill>
-            <a:srgbClr val="1E293B"/>
+            <a:srgbClr val="12192A"/>
           </a:solidFill>
           <a:ln w="15240">
             <a:solidFill>
@@ -4831,7 +4876,7 @@
         </p:nvSpPr>
         <p:spPr>
           <a:xfrm>
-            <a:off x="6400800" y="3154680"/>
+            <a:off x="6400800" y="3172968"/>
             <a:ext cx="4876495" cy="320040"/>
           </a:xfrm>
           <a:prstGeom prst="rect">
@@ -4846,7 +4891,7 @@
           <a:lstStyle/>
           <a:p>
             <a:pPr>
-              <a:defRPr sz="1050" b="1">
+              <a:defRPr sz="1000" b="1">
                 <a:solidFill>
                   <a:srgbClr val="06B6D4"/>
                 </a:solidFill>
@@ -4867,7 +4912,7 @@
         <p:spPr>
           <a:xfrm>
             <a:off x="6400800" y="3474720"/>
-            <a:ext cx="4846320" cy="2651760"/>
+            <a:ext cx="4876495" cy="2651760"/>
           </a:xfrm>
           <a:prstGeom prst="rect">
             <a:avLst/>
@@ -4881,7 +4926,7 @@
           <a:lstStyle/>
           <a:p>
             <a:pPr>
-              <a:defRPr sz="1000" b="1">
+              <a:defRPr sz="950" b="1">
                 <a:solidFill>
                   <a:srgbClr val="F59E0B"/>
                 </a:solidFill>
@@ -4900,12 +4945,12 @@
               </a:defRPr>
             </a:pPr>
             <a:r>
-              <a:t>State: LIVE CCTV | Confidence: 90-98% | Local OpenCV Contour Analysis</a:t>
-            </a:r>
-          </a:p>
-          <a:p>
-            <a:pPr>
-              <a:defRPr sz="1000" b="1">
+              <a:t>State: LIVE ONBOARD | Confidence: 90-98% | Onboard OpenCV contour analysis</a:t>
+            </a:r>
+          </a:p>
+          <a:p>
+            <a:pPr>
+              <a:defRPr sz="950" b="1">
                 <a:solidFill>
                   <a:srgbClr val="F59E0B"/>
                 </a:solidFill>
@@ -4924,12 +4969,12 @@
               </a:defRPr>
             </a:pPr>
             <a:r>
-              <a:t>State: LIVE SENSOR | Confidence: 85-92% | Optical / Weight telemetry</a:t>
-            </a:r>
-          </a:p>
-          <a:p>
-            <a:pPr>
-              <a:defRPr sz="1000" b="1">
+              <a:t>State: LIVE SENSOR | Confidence: 85-92% | Optical / Weight sensors</a:t>
+            </a:r>
+          </a:p>
+          <a:p>
+            <a:pPr>
+              <a:defRPr sz="950" b="1">
                 <a:solidFill>
                   <a:srgbClr val="F59E0B"/>
                 </a:solidFill>
@@ -4948,19 +4993,19 @@
               </a:defRPr>
             </a:pPr>
             <a:r>
-              <a:t>State: PREDICTED | Confidence: 70-85% | Gradient Boosted Classifier</a:t>
-            </a:r>
-          </a:p>
-          <a:p>
-            <a:pPr>
-              <a:defRPr sz="1000" b="1">
+              <a:t>State: SMART ESTIMATE | Confidence: 70-85% | Gradient Boosted Classifier</a:t>
+            </a:r>
+          </a:p>
+          <a:p>
+            <a:pPr>
+              <a:defRPr sz="950" b="1">
                 <a:solidFill>
                   <a:srgbClr val="F59E0B"/>
                 </a:solidFill>
               </a:defRPr>
             </a:pPr>
             <a:r>
-              <a:t>Tier 4: Historical Baseline</a:t>
+              <a:t>Tier 4: Historical Baseline Table</a:t>
             </a:r>
           </a:p>
           <a:p>
@@ -4972,12 +5017,12 @@
               </a:defRPr>
             </a:pPr>
             <a:r>
-              <a:t>State: HISTORICAL | Confidence: 50-70% | Time-of-day stop averages</a:t>
-            </a:r>
-          </a:p>
-          <a:p>
-            <a:pPr>
-              <a:defRPr sz="1000" b="1">
+              <a:t>State: TYPICAL PATTERN | Confidence: 50-70% | Time-of-day stop averages</a:t>
+            </a:r>
+          </a:p>
+          <a:p>
+            <a:pPr>
+              <a:defRPr sz="950" b="1">
                 <a:solidFill>
                   <a:srgbClr val="F59E0B"/>
                 </a:solidFill>
@@ -4996,7 +5041,7 @@
               </a:defRPr>
             </a:pPr>
             <a:r>
-              <a:t>State: UNKNOWN | Confidence: 0% | Marked unverified to commuter</a:t>
+              <a:t>State: UNKNOWN | Confidence: 0% | Marked unverified to commuters</a:t>
             </a:r>
           </a:p>
         </p:txBody>
@@ -5034,11 +5079,11 @@
             <a:avLst/>
           </a:prstGeom>
           <a:solidFill>
-            <a:srgbClr val="0F172A"/>
+            <a:srgbClr val="0B0F19"/>
           </a:solidFill>
           <a:ln>
             <a:solidFill>
-              <a:srgbClr val="0F172A"/>
+              <a:srgbClr val="0B0F19"/>
             </a:solidFill>
           </a:ln>
         </p:spPr>
@@ -5073,7 +5118,7 @@
         <p:spPr>
           <a:xfrm>
             <a:off x="731520" y="365760"/>
-            <a:ext cx="10728655" cy="822960"/>
+            <a:ext cx="10728655" cy="868680"/>
           </a:xfrm>
           <a:prstGeom prst="rect">
             <a:avLst/>
@@ -5094,19 +5139,19 @@
               </a:defRPr>
             </a:pPr>
             <a:r>
-              <a:t>CHAPTER 03 // TECHNICAL MONOGRAPH // TRANSIT INTELLIGENCE SYSTEMS</a:t>
-            </a:r>
-          </a:p>
-          <a:p>
-            <a:pPr>
-              <a:defRPr sz="2000" b="1">
+              <a:t>CHAPTER III // TECHNICAL MONOGRAPH // YATRIQ TRANSIT INTELLIGENCE</a:t>
+            </a:r>
+          </a:p>
+          <a:p>
+            <a:pPr>
+              <a:defRPr sz="2100" b="1">
                 <a:solidFill>
                   <a:srgbClr val="F8FAFC"/>
                 </a:solidFill>
               </a:defRPr>
             </a:pPr>
             <a:r>
-              <a:t>Edge-AI Computer Vision &amp; Offline Resilience</a:t>
+              <a:t>Edge-AI Vision &amp; Offline Resilience Engineering</a:t>
             </a:r>
           </a:p>
           <a:p>
@@ -5118,7 +5163,7 @@
               </a:defRPr>
             </a:pPr>
             <a:r>
-              <a:t>Privacy-Preserving On-Vehicle Cabin Analytics and SQLite WAL Disconnection Tolerance</a:t>
+              <a:t>Privacy-Preserving Onboard Computer Vision and SQLite WAL Disconnection Tolerance</a:t>
             </a:r>
           </a:p>
         </p:txBody>
@@ -5131,8 +5176,8 @@
         </p:nvSpPr>
         <p:spPr>
           <a:xfrm>
-            <a:off x="10058400" y="365760"/>
-            <a:ext cx="1371600" cy="457200"/>
+            <a:off x="9875520" y="365760"/>
+            <a:ext cx="1584655" cy="365760"/>
           </a:xfrm>
           <a:prstGeom prst="rect">
             <a:avLst/>
@@ -5146,7 +5191,7 @@
           <a:lstStyle/>
           <a:p>
             <a:pPr algn="r">
-              <a:defRPr sz="1000" b="1">
+              <a:defRPr sz="1050" b="1">
                 <a:solidFill>
                   <a:srgbClr val="F59E0B"/>
                 </a:solidFill>
@@ -5166,18 +5211,18 @@
         </p:nvSpPr>
         <p:spPr>
           <a:xfrm>
-            <a:off x="731520" y="1234440"/>
+            <a:off x="731520" y="1280160"/>
             <a:ext cx="10728655" cy="18288"/>
           </a:xfrm>
           <a:prstGeom prst="rect">
             <a:avLst/>
           </a:prstGeom>
           <a:solidFill>
-            <a:srgbClr val="334155"/>
+            <a:srgbClr val="22304D"/>
           </a:solidFill>
           <a:ln>
             <a:solidFill>
-              <a:srgbClr val="334155"/>
+              <a:srgbClr val="22304D"/>
             </a:solidFill>
           </a:ln>
         </p:spPr>
@@ -5211,14 +5256,14 @@
         </p:nvSpPr>
         <p:spPr>
           <a:xfrm>
-            <a:off x="731520" y="1463040"/>
-            <a:ext cx="5212080" cy="4846320"/>
+            <a:off x="731520" y="1508760"/>
+            <a:ext cx="5212080" cy="4800600"/>
           </a:xfrm>
           <a:prstGeom prst="roundRect">
             <a:avLst/>
           </a:prstGeom>
           <a:solidFill>
-            <a:srgbClr val="1E293B"/>
+            <a:srgbClr val="12192A"/>
           </a:solidFill>
           <a:ln w="15240">
             <a:solidFill>
@@ -5256,7 +5301,7 @@
         </p:nvSpPr>
         <p:spPr>
           <a:xfrm>
-            <a:off x="914400" y="1600200"/>
+            <a:off x="914400" y="1618488"/>
             <a:ext cx="4846320" cy="320040"/>
           </a:xfrm>
           <a:prstGeom prst="rect">
@@ -5271,14 +5316,14 @@
           <a:lstStyle/>
           <a:p>
             <a:pPr>
-              <a:defRPr sz="1050" b="1">
+              <a:defRPr sz="1000" b="1">
                 <a:solidFill>
                   <a:srgbClr val="06B6D4"/>
                 </a:solidFill>
               </a:defRPr>
             </a:pPr>
             <a:r>
-              <a:t>EDGE COMPUTER VISION &amp; ANTI-FLICKER FILTER</a:t>
+              <a:t>01. ONBOARD COMPUTER VISION &amp; ANTI-FLICKER</a:t>
             </a:r>
           </a:p>
         </p:txBody>
@@ -5291,7 +5336,7 @@
         </p:nvSpPr>
         <p:spPr>
           <a:xfrm>
-            <a:off x="914400" y="1920240"/>
+            <a:off x="914400" y="1965960"/>
             <a:ext cx="4846320" cy="4206240"/>
           </a:xfrm>
           <a:prstGeom prst="rect">
@@ -5306,7 +5351,7 @@
           <a:lstStyle/>
           <a:p>
             <a:pPr>
-              <a:defRPr sz="1050" b="1">
+              <a:defRPr sz="1000" b="1">
                 <a:solidFill>
                   <a:srgbClr val="06B6D4"/>
                 </a:solidFill>
@@ -5318,24 +5363,24 @@
           </a:p>
           <a:p>
             <a:pPr>
-              <a:defRPr sz="900">
+              <a:defRPr sz="850">
                 <a:solidFill>
                   <a:srgbClr val="F8FAFC"/>
                 </a:solidFill>
               </a:defRPr>
             </a:pPr>
             <a:r>
-              <a:t>Raw camera streams NEVER leave the bus. Frame processing is executed locally on edge hardware (Jetson / Pi 4), ensuring 100% commuter privacy under DPDP act.</a:t>
-            </a:r>
-          </a:p>
-          <a:p>
-            <a:pPr>
-              <a:defRPr sz="300"/>
-            </a:pPr>
-          </a:p>
-          <a:p>
-            <a:pPr>
-              <a:defRPr sz="1050" b="1">
+              <a:t>Raw video frames NEVER leave the vehicle. All processing runs locally on Raspberry Pi 4 / Jetson Nano, guaranteeing 100% commuter privacy under Indian DPDP regulations.</a:t>
+            </a:r>
+          </a:p>
+          <a:p>
+            <a:pPr>
+              <a:defRPr sz="250"/>
+            </a:pPr>
+          </a:p>
+          <a:p>
+            <a:pPr>
+              <a:defRPr sz="1000" b="1">
                 <a:solidFill>
                   <a:srgbClr val="06B6D4"/>
                 </a:solidFill>
@@ -5347,24 +5392,24 @@
           </a:p>
           <a:p>
             <a:pPr>
-              <a:defRPr sz="900">
+              <a:defRPr sz="850">
                 <a:solidFill>
                   <a:srgbClr val="F8FAFC"/>
                 </a:solidFill>
               </a:defRPr>
             </a:pPr>
             <a:r>
-              <a:t>Frames are converted to grayscale -&gt; Gaussian blur -&gt; background subtraction -&gt; contour bounding box area estimation to compute cabin occupancy ratio.</a:t>
-            </a:r>
-          </a:p>
-          <a:p>
-            <a:pPr>
-              <a:defRPr sz="300"/>
-            </a:pPr>
-          </a:p>
-          <a:p>
-            <a:pPr>
-              <a:defRPr sz="1050" b="1">
+              <a:t>Frames undergo Gaussian blur -&gt; background subtraction -&gt; contour bounding box area estimation to compute cabin occupancy ratio without face recognition.</a:t>
+            </a:r>
+          </a:p>
+          <a:p>
+            <a:pPr>
+              <a:defRPr sz="250"/>
+            </a:pPr>
+          </a:p>
+          <a:p>
+            <a:pPr>
+              <a:defRPr sz="1000" b="1">
                 <a:solidFill>
                   <a:srgbClr val="06B6D4"/>
                 </a:solidFill>
@@ -5376,14 +5421,14 @@
           </a:p>
           <a:p>
             <a:pPr>
-              <a:defRPr sz="900">
+              <a:defRPr sz="850">
                 <a:solidFill>
                   <a:srgbClr val="F8FAFC"/>
                 </a:solidFill>
               </a:defRPr>
             </a:pPr>
             <a:r>
-              <a:t>Raw camera outputs fluctuate with passenger movement. A 3-window temporal filter prevents UI label thrashing:</a:t>
+              <a:t>Raw camera outputs fluctuate with passenger movement. A 3-window filter prevents UI label thrashing:</a:t>
             </a:r>
             <a:br/>
             <a:r>
@@ -5391,48 +5436,48 @@
             </a:r>
             <a:br/>
             <a:r>
-              <a:t>Only changes category if confirmed across multiple consecutive sample windows.</a:t>
-            </a:r>
-          </a:p>
-          <a:p>
-            <a:pPr>
-              <a:defRPr sz="300"/>
-            </a:pPr>
-          </a:p>
-          <a:p>
-            <a:pPr>
-              <a:defRPr sz="1050" b="1">
+              <a:t>Only shifts category when confirmed across multiple consecutive sample windows.</a:t>
+            </a:r>
+          </a:p>
+          <a:p>
+            <a:pPr>
+              <a:defRPr sz="250"/>
+            </a:pPr>
+          </a:p>
+          <a:p>
+            <a:pPr>
+              <a:defRPr sz="1000" b="1">
                 <a:solidFill>
                   <a:srgbClr val="06B6D4"/>
                 </a:solidFill>
               </a:defRPr>
             </a:pPr>
             <a:r>
-              <a:t>4. Density Categorization Thresholds</a:t>
-            </a:r>
-          </a:p>
-          <a:p>
-            <a:pPr>
-              <a:defRPr sz="900">
+              <a:t>4. Calm Humanized Density Labels</a:t>
+            </a:r>
+          </a:p>
+          <a:p>
+            <a:pPr>
+              <a:defRPr sz="850">
                 <a:solidFill>
                   <a:srgbClr val="F8FAFC"/>
                 </a:solidFill>
               </a:defRPr>
             </a:pPr>
             <a:r>
-              <a:t>  LOW: 0-35% occupancy (&lt;21 seated / no standees)</a:t>
+              <a:t>  PLENTY OF SEATS (0-35% occupancy, all seated)</a:t>
             </a:r>
             <a:br/>
             <a:r>
-              <a:t>  MEDIUM: 36-70% occupancy (full seats, light aisle)</a:t>
+              <a:t>  SEATS FILLING (36-70% occupancy, light aisle)</a:t>
             </a:r>
             <a:br/>
             <a:r>
-              <a:t>  HIGH: 71-95% occupancy (dense standing)</a:t>
+              <a:t>  FEW SEATS LEFT (71-95% occupancy, dense aisle)</a:t>
             </a:r>
             <a:br/>
             <a:r>
-              <a:t>  VERY HIGH: &gt;95% (crush load / boarding delayed)</a:t>
+              <a:t>  STANDING ROOM ONLY (&gt;95% crush load)</a:t>
             </a:r>
           </a:p>
         </p:txBody>
@@ -5445,14 +5490,14 @@
         </p:nvSpPr>
         <p:spPr>
           <a:xfrm>
-            <a:off x="6217920" y="1463040"/>
-            <a:ext cx="5242255" cy="4846320"/>
+            <a:off x="6217920" y="1508760"/>
+            <a:ext cx="5242255" cy="4800600"/>
           </a:xfrm>
           <a:prstGeom prst="roundRect">
             <a:avLst/>
           </a:prstGeom>
           <a:solidFill>
-            <a:srgbClr val="1E293B"/>
+            <a:srgbClr val="12192A"/>
           </a:solidFill>
           <a:ln w="15240">
             <a:solidFill>
@@ -5490,7 +5535,7 @@
         </p:nvSpPr>
         <p:spPr>
           <a:xfrm>
-            <a:off x="6400800" y="1600200"/>
+            <a:off x="6400800" y="1618488"/>
             <a:ext cx="4876495" cy="320040"/>
           </a:xfrm>
           <a:prstGeom prst="rect">
@@ -5505,14 +5550,14 @@
           <a:lstStyle/>
           <a:p>
             <a:pPr>
-              <a:defRPr sz="1050" b="1">
+              <a:defRPr sz="1000" b="1">
                 <a:solidFill>
                   <a:srgbClr val="06B6D4"/>
                 </a:solidFill>
               </a:defRPr>
             </a:pPr>
             <a:r>
-              <a:t>OFFLINE-FIRST SQLITE BUFFER MECHANICS</a:t>
+              <a:t>02. SQLITE WAL OFFLINE BUFFER MECHANICS</a:t>
             </a:r>
           </a:p>
         </p:txBody>
@@ -5525,8 +5570,8 @@
         </p:nvSpPr>
         <p:spPr>
           <a:xfrm>
-            <a:off x="6400800" y="1920240"/>
-            <a:ext cx="4846320" cy="4206240"/>
+            <a:off x="6400800" y="1965960"/>
+            <a:ext cx="4876495" cy="4206240"/>
           </a:xfrm>
           <a:prstGeom prst="rect">
             <a:avLst/>
@@ -5540,19 +5585,19 @@
           <a:lstStyle/>
           <a:p>
             <a:pPr>
-              <a:defRPr sz="1050" b="1">
+              <a:defRPr sz="1000" b="1">
                 <a:solidFill>
                   <a:srgbClr val="F59E0B"/>
                 </a:solidFill>
               </a:defRPr>
             </a:pPr>
             <a:r>
-              <a:t>The Cellular Blackspot Dilemma</a:t>
-            </a:r>
-          </a:p>
-          <a:p>
-            <a:pPr>
-              <a:defRPr sz="900">
+              <a:t>The Cellular Blackspot Challenge</a:t>
+            </a:r>
+          </a:p>
+          <a:p>
+            <a:pPr>
+              <a:defRPr sz="850">
                 <a:solidFill>
                   <a:srgbClr val="F8FAFC"/>
                 </a:solidFill>
@@ -5564,12 +5609,12 @@
           </a:p>
           <a:p>
             <a:pPr>
-              <a:defRPr sz="300"/>
-            </a:pPr>
-          </a:p>
-          <a:p>
-            <a:pPr>
-              <a:defRPr sz="1050" b="1">
+              <a:defRPr sz="250"/>
+            </a:pPr>
+          </a:p>
+          <a:p>
+            <a:pPr>
+              <a:defRPr sz="1000" b="1">
                 <a:solidFill>
                   <a:srgbClr val="F59E0B"/>
                 </a:solidFill>
@@ -5581,7 +5626,7 @@
           </a:p>
           <a:p>
             <a:pPr>
-              <a:defRPr sz="900">
+              <a:defRPr sz="850">
                 <a:solidFill>
                   <a:srgbClr val="F8FAFC"/>
                 </a:solidFill>
@@ -5593,12 +5638,12 @@
           </a:p>
           <a:p>
             <a:pPr>
-              <a:defRPr sz="300"/>
-            </a:pPr>
-          </a:p>
-          <a:p>
-            <a:pPr>
-              <a:defRPr sz="1050" b="1">
+              <a:defRPr sz="250"/>
+            </a:pPr>
+          </a:p>
+          <a:p>
+            <a:pPr>
+              <a:defRPr sz="1000" b="1">
                 <a:solidFill>
                   <a:srgbClr val="F59E0B"/>
                 </a:solidFill>
@@ -5610,7 +5655,7 @@
           </a:p>
           <a:p>
             <a:pPr>
-              <a:defRPr sz="900">
+              <a:defRPr sz="850">
                 <a:solidFill>
                   <a:srgbClr val="F8FAFC"/>
                 </a:solidFill>
@@ -5622,31 +5667,31 @@
           </a:p>
           <a:p>
             <a:pPr>
-              <a:defRPr sz="300"/>
-            </a:pPr>
-          </a:p>
-          <a:p>
-            <a:pPr>
-              <a:defRPr sz="1050" b="1">
+              <a:defRPr sz="250"/>
+            </a:pPr>
+          </a:p>
+          <a:p>
+            <a:pPr>
+              <a:defRPr sz="1000" b="1">
                 <a:solidFill>
                   <a:srgbClr val="F59E0B"/>
                 </a:solidFill>
               </a:defRPr>
             </a:pPr>
             <a:r>
-              <a:t>Truth Engine Out-of-Order Ingestion</a:t>
-            </a:r>
-          </a:p>
-          <a:p>
-            <a:pPr>
-              <a:defRPr sz="900">
+              <a:t>Historical Audit Protection</a:t>
+            </a:r>
+          </a:p>
+          <a:p>
+            <a:pPr>
+              <a:defRPr sz="850">
                 <a:solidFill>
                   <a:srgbClr val="F8FAFC"/>
                 </a:solidFill>
               </a:defRPr>
             </a:pPr>
             <a:r>
-              <a:t>The backend inserts buffered data into historical telemetry tables for ML training and model audits, but NEVER overrides current live vehicle positions with stale historical pings.</a:t>
+              <a:t>The backend preserves replayed pings for ML training but NEVER overrides current live vehicle positions with stale historical pings.</a:t>
             </a:r>
           </a:p>
         </p:txBody>
@@ -5684,11 +5729,11 @@
             <a:avLst/>
           </a:prstGeom>
           <a:solidFill>
-            <a:srgbClr val="0F172A"/>
+            <a:srgbClr val="0B0F19"/>
           </a:solidFill>
           <a:ln>
             <a:solidFill>
-              <a:srgbClr val="0F172A"/>
+              <a:srgbClr val="0B0F19"/>
             </a:solidFill>
           </a:ln>
         </p:spPr>
@@ -5723,7 +5768,7 @@
         <p:spPr>
           <a:xfrm>
             <a:off x="731520" y="365760"/>
-            <a:ext cx="10728655" cy="822960"/>
+            <a:ext cx="10728655" cy="868680"/>
           </a:xfrm>
           <a:prstGeom prst="rect">
             <a:avLst/>
@@ -5744,12 +5789,12 @@
               </a:defRPr>
             </a:pPr>
             <a:r>
-              <a:t>CHAPTER 04 // TECHNICAL MONOGRAPH // TRANSIT INTELLIGENCE SYSTEMS</a:t>
-            </a:r>
-          </a:p>
-          <a:p>
-            <a:pPr>
-              <a:defRPr sz="2000" b="1">
+              <a:t>CHAPTER IV // TECHNICAL MONOGRAPH // YATRIQ TRANSIT INTELLIGENCE</a:t>
+            </a:r>
+          </a:p>
+          <a:p>
+            <a:pPr>
+              <a:defRPr sz="2100" b="1">
                 <a:solidFill>
                   <a:srgbClr val="F8FAFC"/>
                 </a:solidFill>
@@ -5781,8 +5826,8 @@
         </p:nvSpPr>
         <p:spPr>
           <a:xfrm>
-            <a:off x="10058400" y="365760"/>
-            <a:ext cx="1371600" cy="457200"/>
+            <a:off x="9875520" y="365760"/>
+            <a:ext cx="1584655" cy="365760"/>
           </a:xfrm>
           <a:prstGeom prst="rect">
             <a:avLst/>
@@ -5796,7 +5841,7 @@
           <a:lstStyle/>
           <a:p>
             <a:pPr algn="r">
-              <a:defRPr sz="1000" b="1">
+              <a:defRPr sz="1050" b="1">
                 <a:solidFill>
                   <a:srgbClr val="F59E0B"/>
                 </a:solidFill>
@@ -5816,18 +5861,18 @@
         </p:nvSpPr>
         <p:spPr>
           <a:xfrm>
-            <a:off x="731520" y="1234440"/>
+            <a:off x="731520" y="1280160"/>
             <a:ext cx="10728655" cy="18288"/>
           </a:xfrm>
           <a:prstGeom prst="rect">
             <a:avLst/>
           </a:prstGeom>
           <a:solidFill>
-            <a:srgbClr val="334155"/>
+            <a:srgbClr val="22304D"/>
           </a:solidFill>
           <a:ln>
             <a:solidFill>
-              <a:srgbClr val="334155"/>
+              <a:srgbClr val="22304D"/>
             </a:solidFill>
           </a:ln>
         </p:spPr>
@@ -5861,14 +5906,14 @@
         </p:nvSpPr>
         <p:spPr>
           <a:xfrm>
-            <a:off x="731520" y="1463040"/>
-            <a:ext cx="10728655" cy="1645920"/>
+            <a:off x="731520" y="1508760"/>
+            <a:ext cx="10728655" cy="1600200"/>
           </a:xfrm>
           <a:prstGeom prst="roundRect">
             <a:avLst/>
           </a:prstGeom>
           <a:solidFill>
-            <a:srgbClr val="1E293B"/>
+            <a:srgbClr val="12192A"/>
           </a:solidFill>
           <a:ln w="15240">
             <a:solidFill>
@@ -5906,7 +5951,7 @@
         </p:nvSpPr>
         <p:spPr>
           <a:xfrm>
-            <a:off x="914400" y="1600200"/>
+            <a:off x="914400" y="1618488"/>
             <a:ext cx="10362895" cy="320040"/>
           </a:xfrm>
           <a:prstGeom prst="rect">
@@ -5921,14 +5966,14 @@
           <a:lstStyle/>
           <a:p>
             <a:pPr>
-              <a:defRPr sz="1050" b="1">
+              <a:defRPr sz="1000" b="1">
                 <a:solidFill>
                   <a:srgbClr val="06B6D4"/>
                 </a:solidFill>
               </a:defRPr>
             </a:pPr>
             <a:r>
-              <a:t>GEOSPATIAL SNAPPING &amp; CORRIDOR PROGRESSION FORMULAS</a:t>
+              <a:t>GEOSPATIAL NAVIGATION &amp; PROJECTION CALCULUS</a:t>
             </a:r>
           </a:p>
         </p:txBody>
@@ -5967,11 +6012,11 @@
             </a:r>
             <a:br/>
             <a:r>
-              <a:t>2. Cross-Track Error (XTE): XTE = R * arcsin(sin(d_13/R) * sin(bearing_13 - bearing_12))  |  Snapping Threshold: epsilon &lt;= 55m</a:t>
+              <a:t>2. Cross-Track Error (XTE): XTE = R * arcsin(sin(d_13/R) * sin(bearing_13 - bearing_12))  |  Road Snapping: epsilon &lt;= 55m</a:t>
             </a:r>
             <a:br/>
             <a:r>
-              <a:t>3. Corridor Progression Index: P = (Distance from Terminal A) / (Total Corridor Length L_total) in [0.000, 1.000]</a:t>
+              <a:t>3. Corridor Progression Index: P = (Distance along polyline from Terminal A) / (Total Length L_total) in [0.000, 1.000]</a:t>
             </a:r>
             <a:br/>
             <a:r>
@@ -5995,11 +6040,11 @@
             <a:avLst/>
           </a:prstGeom>
           <a:solidFill>
-            <a:srgbClr val="1E293B"/>
+            <a:srgbClr val="12192A"/>
           </a:solidFill>
           <a:ln w="15240">
             <a:solidFill>
-              <a:srgbClr val="334155"/>
+              <a:srgbClr val="22304D"/>
             </a:solidFill>
           </a:ln>
         </p:spPr>
@@ -6033,7 +6078,7 @@
         </p:nvSpPr>
         <p:spPr>
           <a:xfrm>
-            <a:off x="914400" y="3429000"/>
+            <a:off x="914400" y="3401568"/>
             <a:ext cx="6035040" cy="320040"/>
           </a:xfrm>
           <a:prstGeom prst="rect">
@@ -6048,7 +6093,7 @@
           <a:lstStyle/>
           <a:p>
             <a:pPr>
-              <a:defRPr sz="1050" b="1">
+              <a:defRPr sz="1000" b="1">
                 <a:solidFill>
                   <a:srgbClr val="06B6D4"/>
                 </a:solidFill>
@@ -6134,7 +6179,7 @@
             <a:avLst/>
           </a:prstGeom>
           <a:solidFill>
-            <a:srgbClr val="1E293B"/>
+            <a:srgbClr val="12192A"/>
           </a:solidFill>
           <a:ln w="15240">
             <a:solidFill>
@@ -6172,7 +6217,7 @@
         </p:nvSpPr>
         <p:spPr>
           <a:xfrm>
-            <a:off x="7498080" y="3429000"/>
+            <a:off x="7498080" y="3401568"/>
             <a:ext cx="3779215" cy="320040"/>
           </a:xfrm>
           <a:prstGeom prst="rect">
@@ -6187,7 +6232,7 @@
           <a:lstStyle/>
           <a:p>
             <a:pPr>
-              <a:defRPr sz="1050" b="1">
+              <a:defRPr sz="1000" b="1">
                 <a:solidFill>
                   <a:srgbClr val="06B6D4"/>
                 </a:solidFill>
@@ -6208,7 +6253,7 @@
         <p:spPr>
           <a:xfrm>
             <a:off x="7498079" y="3703320"/>
-            <a:ext cx="3749039" cy="2468880"/>
+            <a:ext cx="3779215" cy="2468880"/>
           </a:xfrm>
           <a:prstGeom prst="rect">
             <a:avLst/>
@@ -6222,7 +6267,7 @@
           <a:lstStyle/>
           <a:p>
             <a:pPr>
-              <a:defRPr sz="900">
+              <a:defRPr sz="880">
                 <a:solidFill>
                   <a:srgbClr val="F8FAFC"/>
                 </a:solidFill>
@@ -6237,7 +6282,7 @@
             </a:r>
             <a:br/>
             <a:r>
-              <a:t>- Dynamic Heatmaps: Track segments glow based on passenger density (Green = Low, Amber = Med, Red = High).</a:t>
+              <a:t>- Dynamic Heatmaps: Track segments glow based on passenger density (Green = Plenty of Seats, Amber = Moderate, Red = Full).</a:t>
             </a:r>
             <a:br/>
             <a:r>
@@ -6279,11 +6324,11 @@
             <a:avLst/>
           </a:prstGeom>
           <a:solidFill>
-            <a:srgbClr val="0F172A"/>
+            <a:srgbClr val="0B0F19"/>
           </a:solidFill>
           <a:ln>
             <a:solidFill>
-              <a:srgbClr val="0F172A"/>
+              <a:srgbClr val="0B0F19"/>
             </a:solidFill>
           </a:ln>
         </p:spPr>
@@ -6318,7 +6363,7 @@
         <p:spPr>
           <a:xfrm>
             <a:off x="731520" y="365760"/>
-            <a:ext cx="10728655" cy="822960"/>
+            <a:ext cx="10728655" cy="868680"/>
           </a:xfrm>
           <a:prstGeom prst="rect">
             <a:avLst/>
@@ -6339,19 +6384,19 @@
               </a:defRPr>
             </a:pPr>
             <a:r>
-              <a:t>CHAPTER 05 // TECHNICAL MONOGRAPH // TRANSIT INTELLIGENCE SYSTEMS</a:t>
-            </a:r>
-          </a:p>
-          <a:p>
-            <a:pPr>
-              <a:defRPr sz="2000" b="1">
+              <a:t>CHAPTER V // TECHNICAL MONOGRAPH // YATRIQ TRANSIT INTELLIGENCE</a:t>
+            </a:r>
+          </a:p>
+          <a:p>
+            <a:pPr>
+              <a:defRPr sz="2100" b="1">
                 <a:solidFill>
                   <a:srgbClr val="F8FAFC"/>
                 </a:solidFill>
               </a:defRPr>
             </a:pPr>
             <a:r>
-              <a:t>Commuter Decision Engine &amp; Transparent UX</a:t>
+              <a:t>Commuter Decision Engine &amp; Calm UX Architecture</a:t>
             </a:r>
           </a:p>
           <a:p>
@@ -6363,7 +6408,7 @@
               </a:defRPr>
             </a:pPr>
             <a:r>
-              <a:t>Load-Balancing Commuters via FASTEST vs. COMFORTABLE Recommendations &amp; Provenance Badges</a:t>
+              <a:t>Eliminating Commuter Anxiety with Hero Recommendations, Humanized Density &amp; 2m Alerts</a:t>
             </a:r>
           </a:p>
         </p:txBody>
@@ -6376,8 +6421,8 @@
         </p:nvSpPr>
         <p:spPr>
           <a:xfrm>
-            <a:off x="10058400" y="365760"/>
-            <a:ext cx="1371600" cy="457200"/>
+            <a:off x="9875520" y="365760"/>
+            <a:ext cx="1584655" cy="365760"/>
           </a:xfrm>
           <a:prstGeom prst="rect">
             <a:avLst/>
@@ -6391,7 +6436,7 @@
           <a:lstStyle/>
           <a:p>
             <a:pPr algn="r">
-              <a:defRPr sz="1000" b="1">
+              <a:defRPr sz="1050" b="1">
                 <a:solidFill>
                   <a:srgbClr val="F59E0B"/>
                 </a:solidFill>
@@ -6411,18 +6456,18 @@
         </p:nvSpPr>
         <p:spPr>
           <a:xfrm>
-            <a:off x="731520" y="1234440"/>
+            <a:off x="731520" y="1280160"/>
             <a:ext cx="10728655" cy="18288"/>
           </a:xfrm>
           <a:prstGeom prst="rect">
             <a:avLst/>
           </a:prstGeom>
           <a:solidFill>
-            <a:srgbClr val="334155"/>
+            <a:srgbClr val="22304D"/>
           </a:solidFill>
           <a:ln>
             <a:solidFill>
-              <a:srgbClr val="334155"/>
+              <a:srgbClr val="22304D"/>
             </a:solidFill>
           </a:ln>
         </p:spPr>
@@ -6456,14 +6501,14 @@
         </p:nvSpPr>
         <p:spPr>
           <a:xfrm>
-            <a:off x="731520" y="1463040"/>
-            <a:ext cx="5212080" cy="4846320"/>
+            <a:off x="731520" y="1508760"/>
+            <a:ext cx="5212080" cy="4800600"/>
           </a:xfrm>
           <a:prstGeom prst="roundRect">
             <a:avLst/>
           </a:prstGeom>
           <a:solidFill>
-            <a:srgbClr val="1E293B"/>
+            <a:srgbClr val="12192A"/>
           </a:solidFill>
           <a:ln w="15240">
             <a:solidFill>
@@ -6501,7 +6546,7 @@
         </p:nvSpPr>
         <p:spPr>
           <a:xfrm>
-            <a:off x="914400" y="1600200"/>
+            <a:off x="914400" y="1618488"/>
             <a:ext cx="4846320" cy="320040"/>
           </a:xfrm>
           <a:prstGeom prst="rect">
@@ -6516,14 +6561,14 @@
           <a:lstStyle/>
           <a:p>
             <a:pPr>
-              <a:defRPr sz="1050" b="1">
+              <a:defRPr sz="1000" b="1">
                 <a:solidFill>
                   <a:srgbClr val="06B6D4"/>
                 </a:solidFill>
               </a:defRPr>
             </a:pPr>
             <a:r>
-              <a:t>DYNAMIC COMMUTER RECOMMENDATION LOGIC</a:t>
+              <a:t>01. ACTIVE CORRIDOR LOAD BALANCING</a:t>
             </a:r>
           </a:p>
         </p:txBody>
@@ -6536,7 +6581,7 @@
         </p:nvSpPr>
         <p:spPr>
           <a:xfrm>
-            <a:off x="914400" y="1920240"/>
+            <a:off x="914400" y="1965960"/>
             <a:ext cx="4846320" cy="4206240"/>
           </a:xfrm>
           <a:prstGeom prst="rect">
@@ -6551,7 +6596,7 @@
           <a:lstStyle/>
           <a:p>
             <a:pPr>
-              <a:defRPr sz="1050" b="1">
+              <a:defRPr sz="1000" b="1">
                 <a:solidFill>
                   <a:srgbClr val="06B6D4"/>
                 </a:solidFill>
@@ -6563,24 +6608,24 @@
           </a:p>
           <a:p>
             <a:pPr>
-              <a:defRPr sz="900">
+              <a:defRPr sz="850">
                 <a:solidFill>
                   <a:srgbClr val="F8FAFC"/>
                 </a:solidFill>
               </a:defRPr>
             </a:pPr>
             <a:r>
-              <a:t>Two buses on Route 101 frequently arrive 4 minutes apart. The first bus is severely overcrowded (95%+), while the trailing bus is nearly empty (30%). Commuters instinctively mob the first bus, aggravating delays.</a:t>
-            </a:r>
-          </a:p>
-          <a:p>
-            <a:pPr>
-              <a:defRPr sz="300"/>
-            </a:pPr>
-          </a:p>
-          <a:p>
-            <a:pPr>
-              <a:defRPr sz="1050" b="1">
+              <a:t>Two buses on Route 101 frequently arrive 4 minutes apart. The first bus is severely overcrowded (98%), while the trailing bus is nearly empty (30%). Commuters instinctively mob the first bus, aggravating delays.</a:t>
+            </a:r>
+          </a:p>
+          <a:p>
+            <a:pPr>
+              <a:defRPr sz="250"/>
+            </a:pPr>
+          </a:p>
+          <a:p>
+            <a:pPr>
+              <a:defRPr sz="1000" b="1">
                 <a:solidFill>
                   <a:srgbClr val="06B6D4"/>
                 </a:solidFill>
@@ -6592,7 +6637,7 @@
           </a:p>
           <a:p>
             <a:pPr>
-              <a:defRPr sz="900">
+              <a:defRPr sz="850">
                 <a:solidFill>
                   <a:srgbClr val="F8FAFC"/>
                 </a:solidFill>
@@ -6603,77 +6648,69 @@
             </a:r>
             <a:br/>
             <a:r>
-              <a:t>  * Badge: FASTEST ARRIVAL</a:t>
+              <a:t>  * Target Commuter: Time-critical passengers, daily office rush.</a:t>
+            </a:r>
+          </a:p>
+          <a:p>
+            <a:pPr>
+              <a:defRPr sz="250"/>
+            </a:pPr>
+          </a:p>
+          <a:p>
+            <a:pPr>
+              <a:defRPr sz="1000" b="1">
+                <a:solidFill>
+                  <a:srgbClr val="06B6D4"/>
+                </a:solidFill>
+              </a:defRPr>
+            </a:pPr>
+            <a:r>
+              <a:t>THE 'MOST COMFORTABLE' RECOMMENDATION</a:t>
+            </a:r>
+          </a:p>
+          <a:p>
+            <a:pPr>
+              <a:defRPr sz="850">
+                <a:solidFill>
+                  <a:srgbClr val="F8FAFC"/>
+                </a:solidFill>
+              </a:defRPr>
+            </a:pPr>
+            <a:r>
+              <a:t>Identifies a trailing vehicle arriving within a delta window (Delta t &lt;= 10 min) with LOW or MEDIUM crowd occupancy.</a:t>
             </a:r>
             <a:br/>
             <a:r>
-              <a:t>  * Commuter Profile: Time-critical passengers, daily office rush.</a:t>
-            </a:r>
-          </a:p>
-          <a:p>
-            <a:pPr>
-              <a:defRPr sz="300"/>
-            </a:pPr>
-          </a:p>
-          <a:p>
-            <a:pPr>
-              <a:defRPr sz="1050" b="1">
+              <a:t>  * Target Commuter: Elderly, families, long-distance commuters desiring guaranteed seats.</a:t>
+            </a:r>
+          </a:p>
+          <a:p>
+            <a:pPr>
+              <a:defRPr sz="250"/>
+            </a:pPr>
+          </a:p>
+          <a:p>
+            <a:pPr>
+              <a:defRPr sz="1000" b="1">
                 <a:solidFill>
                   <a:srgbClr val="06B6D4"/>
                 </a:solidFill>
               </a:defRPr>
             </a:pPr>
             <a:r>
-              <a:t>THE 'MOST COMFORTABLE' RECOMMENDATION</a:t>
-            </a:r>
-          </a:p>
-          <a:p>
-            <a:pPr>
-              <a:defRPr sz="900">
+              <a:t>Empirical Transit Impact</a:t>
+            </a:r>
+          </a:p>
+          <a:p>
+            <a:pPr>
+              <a:defRPr sz="850">
                 <a:solidFill>
                   <a:srgbClr val="F8FAFC"/>
                 </a:solidFill>
               </a:defRPr>
             </a:pPr>
             <a:r>
-              <a:t>Identifies a trailing vehicle arriving within a delta window (Delta t &lt;= 10 min) with LOW or MEDIUM crowd occupancy.</a:t>
-            </a:r>
-            <a:br/>
-            <a:r>
-              <a:t>  * Badge: MOST COMFORTABLE (Guaranteed Seat)</a:t>
-            </a:r>
-            <a:br/>
-            <a:r>
-              <a:t>  * Commuter Profile: Elderly, families, long-distance commuters.</a:t>
-            </a:r>
-          </a:p>
-          <a:p>
-            <a:pPr>
-              <a:defRPr sz="300"/>
-            </a:pPr>
-          </a:p>
-          <a:p>
-            <a:pPr>
-              <a:defRPr sz="1050" b="1">
-                <a:solidFill>
-                  <a:srgbClr val="06B6D4"/>
-                </a:solidFill>
-              </a:defRPr>
-            </a:pPr>
-            <a:r>
-              <a:t>Active Corridor Load Balancing</a:t>
-            </a:r>
-          </a:p>
-          <a:p>
-            <a:pPr>
-              <a:defRPr sz="900">
-                <a:solidFill>
-                  <a:srgbClr val="F8FAFC"/>
-                </a:solidFill>
-              </a:defRPr>
-            </a:pPr>
-            <a:r>
-              <a:t>Simulations demonstrate an 18-24% reduction in peak-door boarding delay by voluntarily distributing passengers to trailing buses.</a:t>
+              <a:t>Simulations demonstrate an 18-24% reduction in peak-door boarding delay by voluntarily distributing passengers across consecutive buses.</a:t>
             </a:r>
           </a:p>
         </p:txBody>
@@ -6686,18 +6723,18 @@
         </p:nvSpPr>
         <p:spPr>
           <a:xfrm>
-            <a:off x="6217920" y="1463040"/>
-            <a:ext cx="5242255" cy="4846320"/>
+            <a:off x="6217920" y="1508760"/>
+            <a:ext cx="5242255" cy="4800600"/>
           </a:xfrm>
           <a:prstGeom prst="roundRect">
             <a:avLst/>
           </a:prstGeom>
           <a:solidFill>
-            <a:srgbClr val="1E293B"/>
+            <a:srgbClr val="12192A"/>
           </a:solidFill>
           <a:ln w="15240">
             <a:solidFill>
-              <a:srgbClr val="F59E0B"/>
+              <a:srgbClr val="10B981"/>
             </a:solidFill>
           </a:ln>
         </p:spPr>
@@ -6731,7 +6768,7 @@
         </p:nvSpPr>
         <p:spPr>
           <a:xfrm>
-            <a:off x="6400800" y="1600200"/>
+            <a:off x="6400800" y="1618488"/>
             <a:ext cx="4876495" cy="320040"/>
           </a:xfrm>
           <a:prstGeom prst="rect">
@@ -6746,14 +6783,14 @@
           <a:lstStyle/>
           <a:p>
             <a:pPr>
-              <a:defRPr sz="1050" b="1">
+              <a:defRPr sz="1000" b="1">
                 <a:solidFill>
                   <a:srgbClr val="06B6D4"/>
                 </a:solidFill>
               </a:defRPr>
             </a:pPr>
             <a:r>
-              <a:t>TRANSPARENT DATA PROVENANCE &amp; CLIENT STACK</a:t>
+              <a:t>02. CALM COMMUTE UX INNOVATIONS</a:t>
             </a:r>
           </a:p>
         </p:txBody>
@@ -6766,8 +6803,8 @@
         </p:nvSpPr>
         <p:spPr>
           <a:xfrm>
-            <a:off x="6400800" y="1920240"/>
-            <a:ext cx="4846320" cy="4206240"/>
+            <a:off x="6400800" y="1965960"/>
+            <a:ext cx="4876495" cy="4206240"/>
           </a:xfrm>
           <a:prstGeom prst="rect">
             <a:avLst/>
@@ -6781,112 +6818,117 @@
           <a:lstStyle/>
           <a:p>
             <a:pPr>
-              <a:defRPr sz="1050" b="1">
-                <a:solidFill>
-                  <a:srgbClr val="F59E0B"/>
-                </a:solidFill>
-              </a:defRPr>
-            </a:pPr>
-            <a:r>
-              <a:t>Commuter Trust Through Full Provenance</a:t>
-            </a:r>
-          </a:p>
-          <a:p>
-            <a:pPr>
-              <a:defRPr sz="900">
+              <a:defRPr sz="1000" b="1">
+                <a:solidFill>
+                  <a:srgbClr val="10B981"/>
+                </a:solidFill>
+              </a:defRPr>
+            </a:pPr>
+            <a:r>
+              <a:t>Hero 'Best Choice For You' Card</a:t>
+            </a:r>
+          </a:p>
+          <a:p>
+            <a:pPr>
+              <a:defRPr sz="850">
                 <a:solidFill>
                   <a:srgbClr val="F8FAFC"/>
                 </a:solidFill>
               </a:defRPr>
             </a:pPr>
             <a:r>
-              <a:t>Every arrival card displays explicit provenance metadata:</a:t>
+              <a:t>Eliminates decision fatigue. A single prominent card at the top tells the passenger exactly which bus to take, arrival minutes, and seating comfort in under 2 seconds.</a:t>
+            </a:r>
+          </a:p>
+          <a:p>
+            <a:pPr>
+              <a:defRPr sz="250"/>
+            </a:pPr>
+          </a:p>
+          <a:p>
+            <a:pPr>
+              <a:defRPr sz="1000" b="1">
+                <a:solidFill>
+                  <a:srgbClr val="10B981"/>
+                </a:solidFill>
+              </a:defRPr>
+            </a:pPr>
+            <a:r>
+              <a:t>Friendly Humanized Crowd Indicators</a:t>
+            </a:r>
+          </a:p>
+          <a:p>
+            <a:pPr>
+              <a:defRPr sz="850">
+                <a:solidFill>
+                  <a:srgbClr val="F8FAFC"/>
+                </a:solidFill>
+              </a:defRPr>
+            </a:pPr>
+            <a:r>
+              <a:t>Replaces stressful percentages with clear human labels:</a:t>
             </a:r>
             <a:br/>
             <a:r>
-              <a:t>  - LIVE CCTV: Onboard edge camera verified (&lt;60s)</a:t>
-            </a:r>
-            <a:br/>
-            <a:r>
-              <a:t>  - PREDICTED: Machine Learning regressor forecast</a:t>
-            </a:r>
-            <a:br/>
-            <a:r>
-              <a:t>  - HISTORICAL: Deterministic time-of-day fallback</a:t>
-            </a:r>
-            <a:br/>
-            <a:r>
-              <a:t>  - Age tag: 'Updated 14s ago' | Confidence score: 94%</a:t>
-            </a:r>
-          </a:p>
-          <a:p>
-            <a:pPr>
-              <a:defRPr sz="300"/>
-            </a:pPr>
-          </a:p>
-          <a:p>
-            <a:pPr>
-              <a:defRPr sz="1050" b="1">
-                <a:solidFill>
-                  <a:srgbClr val="F59E0B"/>
-                </a:solidFill>
-              </a:defRPr>
-            </a:pPr>
-            <a:r>
-              <a:t>Flutter Cross-Platform Mobile Client</a:t>
-            </a:r>
-          </a:p>
-          <a:p>
-            <a:pPr>
-              <a:defRPr sz="900">
+              <a:t>  * 🟢 Plenty of Seats | 🟡 Seats Filling | 🟠 Few Seats Left | 🔵 Standing Room Only</a:t>
+            </a:r>
+          </a:p>
+          <a:p>
+            <a:pPr>
+              <a:defRPr sz="250"/>
+            </a:pPr>
+          </a:p>
+          <a:p>
+            <a:pPr>
+              <a:defRPr sz="1000" b="1">
+                <a:solidFill>
+                  <a:srgbClr val="10B981"/>
+                </a:solidFill>
+              </a:defRPr>
+            </a:pPr>
+            <a:r>
+              <a:t>Peace-of-Mind 'Remind 2m Before' Ping</a:t>
+            </a:r>
+          </a:p>
+          <a:p>
+            <a:pPr>
+              <a:defRPr sz="850">
                 <a:solidFill>
                   <a:srgbClr val="F8FAFC"/>
                 </a:solidFill>
               </a:defRPr>
             </a:pPr>
             <a:r>
-              <a:t>Built with Dart / Flutter Riverpod with bilingual localization:</a:t>
-            </a:r>
-            <a:br/>
-            <a:r>
-              <a:t>  - English &amp; Hindi UI ('अपनी बस को आने से पहले जानें')</a:t>
-            </a:r>
-            <a:br/>
-            <a:r>
-              <a:t>  - Rapid-transit train-style progression line</a:t>
-            </a:r>
-            <a:br/>
-            <a:r>
-              <a:t>  - Offline caching of stop schedules and corridor routes</a:t>
-            </a:r>
-          </a:p>
-          <a:p>
-            <a:pPr>
-              <a:defRPr sz="300"/>
-            </a:pPr>
-          </a:p>
-          <a:p>
-            <a:pPr>
-              <a:defRPr sz="1050" b="1">
-                <a:solidFill>
-                  <a:srgbClr val="F59E0B"/>
-                </a:solidFill>
-              </a:defRPr>
-            </a:pPr>
-            <a:r>
-              <a:t>Real-Time WebSocket Ingestion</a:t>
-            </a:r>
-          </a:p>
-          <a:p>
-            <a:pPr>
-              <a:defRPr sz="900">
+              <a:t>Commuters click a friendly bell button to get an alert 2 minutes before the bus arrives, allowing them to pocket their phone and listen to music without staring at screens.</a:t>
+            </a:r>
+          </a:p>
+          <a:p>
+            <a:pPr>
+              <a:defRPr sz="250"/>
+            </a:pPr>
+          </a:p>
+          <a:p>
+            <a:pPr>
+              <a:defRPr sz="1000" b="1">
+                <a:solidFill>
+                  <a:srgbClr val="10B981"/>
+                </a:solidFill>
+              </a:defRPr>
+            </a:pPr>
+            <a:r>
+              <a:t>Offline Schedule &amp; Route Reassurance</a:t>
+            </a:r>
+          </a:p>
+          <a:p>
+            <a:pPr>
+              <a:defRPr sz="850">
                 <a:solidFill>
                   <a:srgbClr val="F8FAFC"/>
                 </a:solidFill>
               </a:defRPr>
             </a:pPr>
             <a:r>
-              <a:t>Sub-second liveboard updates over binary WebSockets with zero battery-draining HTTP polling.</a:t>
+              <a:t>Reassuring status badge informs commuters that corridor routes and schedules are saved offline so connectivity blackouts never cause uncertainty.</a:t>
             </a:r>
           </a:p>
         </p:txBody>
@@ -6924,11 +6966,11 @@
             <a:avLst/>
           </a:prstGeom>
           <a:solidFill>
-            <a:srgbClr val="0F172A"/>
+            <a:srgbClr val="0B0F19"/>
           </a:solidFill>
           <a:ln>
             <a:solidFill>
-              <a:srgbClr val="0F172A"/>
+              <a:srgbClr val="0B0F19"/>
             </a:solidFill>
           </a:ln>
         </p:spPr>
@@ -6963,7 +7005,7 @@
         <p:spPr>
           <a:xfrm>
             <a:off x="731520" y="365760"/>
-            <a:ext cx="10728655" cy="822960"/>
+            <a:ext cx="10728655" cy="868680"/>
           </a:xfrm>
           <a:prstGeom prst="rect">
             <a:avLst/>
@@ -6984,19 +7026,19 @@
               </a:defRPr>
             </a:pPr>
             <a:r>
-              <a:t>CHAPTER 06 // TECHNICAL MONOGRAPH // TRANSIT INTELLIGENCE SYSTEMS</a:t>
-            </a:r>
-          </a:p>
-          <a:p>
-            <a:pPr>
-              <a:defRPr sz="2000" b="1">
+              <a:t>CHAPTER VI // TECHNICAL MONOGRAPH // YATRIQ TRANSIT INTELLIGENCE</a:t>
+            </a:r>
+          </a:p>
+          <a:p>
+            <a:pPr>
+              <a:defRPr sz="2100" b="1">
                 <a:solidFill>
                   <a:srgbClr val="F8FAFC"/>
                 </a:solidFill>
               </a:defRPr>
             </a:pPr>
             <a:r>
-              <a:t>Empirical Verification, Fault Tolerance &amp; Specifications</a:t>
+              <a:t>Empirical Verification, Fault Tolerance &amp; Bill of Materials</a:t>
             </a:r>
           </a:p>
           <a:p>
@@ -7008,7 +7050,7 @@
               </a:defRPr>
             </a:pPr>
             <a:r>
-              <a:t>13 Automated Verification Suites, ML Drift Guardrails &amp; Technical Architecture Specifications</a:t>
+              <a:t>13 Automated Verification Suites, ML Drift Circuit Breakers &amp; Full System Specifications</a:t>
             </a:r>
           </a:p>
         </p:txBody>
@@ -7021,8 +7063,8 @@
         </p:nvSpPr>
         <p:spPr>
           <a:xfrm>
-            <a:off x="10058400" y="365760"/>
-            <a:ext cx="1371600" cy="457200"/>
+            <a:off x="9875520" y="365760"/>
+            <a:ext cx="1584655" cy="365760"/>
           </a:xfrm>
           <a:prstGeom prst="rect">
             <a:avLst/>
@@ -7036,7 +7078,7 @@
           <a:lstStyle/>
           <a:p>
             <a:pPr algn="r">
-              <a:defRPr sz="1000" b="1">
+              <a:defRPr sz="1050" b="1">
                 <a:solidFill>
                   <a:srgbClr val="F59E0B"/>
                 </a:solidFill>
@@ -7056,18 +7098,18 @@
         </p:nvSpPr>
         <p:spPr>
           <a:xfrm>
-            <a:off x="731520" y="1234440"/>
+            <a:off x="731520" y="1280160"/>
             <a:ext cx="10728655" cy="18288"/>
           </a:xfrm>
           <a:prstGeom prst="rect">
             <a:avLst/>
           </a:prstGeom>
           <a:solidFill>
-            <a:srgbClr val="334155"/>
+            <a:srgbClr val="22304D"/>
           </a:solidFill>
           <a:ln>
             <a:solidFill>
-              <a:srgbClr val="334155"/>
+              <a:srgbClr val="22304D"/>
             </a:solidFill>
           </a:ln>
         </p:spPr>
@@ -7101,14 +7143,14 @@
         </p:nvSpPr>
         <p:spPr>
           <a:xfrm>
-            <a:off x="731520" y="1463040"/>
-            <a:ext cx="5212080" cy="4846320"/>
+            <a:off x="731520" y="1508760"/>
+            <a:ext cx="5212080" cy="4800600"/>
           </a:xfrm>
           <a:prstGeom prst="roundRect">
             <a:avLst/>
           </a:prstGeom>
           <a:solidFill>
-            <a:srgbClr val="1E293B"/>
+            <a:srgbClr val="12192A"/>
           </a:solidFill>
           <a:ln w="15240">
             <a:solidFill>
@@ -7146,7 +7188,7 @@
         </p:nvSpPr>
         <p:spPr>
           <a:xfrm>
-            <a:off x="914400" y="1600200"/>
+            <a:off x="914400" y="1618488"/>
             <a:ext cx="4846320" cy="320040"/>
           </a:xfrm>
           <a:prstGeom prst="rect">
@@ -7161,14 +7203,14 @@
           <a:lstStyle/>
           <a:p>
             <a:pPr>
-              <a:defRPr sz="1050" b="1">
+              <a:defRPr sz="1000" b="1">
                 <a:solidFill>
                   <a:srgbClr val="06B6D4"/>
                 </a:solidFill>
               </a:defRPr>
             </a:pPr>
             <a:r>
-              <a:t>VERIFICATION TEST MATRIX &amp; FAULT TOLERANCE</a:t>
+              <a:t>01. VERIFICATION TEST MATRIX &amp; FAULT TOLERANCE</a:t>
             </a:r>
           </a:p>
         </p:txBody>
@@ -7181,7 +7223,7 @@
         </p:nvSpPr>
         <p:spPr>
           <a:xfrm>
-            <a:off x="914400" y="1920240"/>
+            <a:off x="914400" y="1965960"/>
             <a:ext cx="4846320" cy="4206240"/>
           </a:xfrm>
           <a:prstGeom prst="rect">
@@ -7196,7 +7238,7 @@
           <a:lstStyle/>
           <a:p>
             <a:pPr>
-              <a:defRPr sz="1000" b="1">
+              <a:defRPr sz="950" b="1">
                 <a:solidFill>
                   <a:srgbClr val="10B981"/>
                 </a:solidFill>
@@ -7225,7 +7267,7 @@
           </a:p>
           <a:p>
             <a:pPr>
-              <a:defRPr sz="1000" b="1">
+              <a:defRPr sz="950" b="1">
                 <a:solidFill>
                   <a:srgbClr val="10B981"/>
                 </a:solidFill>
@@ -7254,7 +7296,7 @@
           </a:p>
           <a:p>
             <a:pPr>
-              <a:defRPr sz="1000" b="1">
+              <a:defRPr sz="950" b="1">
                 <a:solidFill>
                   <a:srgbClr val="10B981"/>
                 </a:solidFill>
@@ -7283,7 +7325,7 @@
           </a:p>
           <a:p>
             <a:pPr>
-              <a:defRPr sz="1000" b="1">
+              <a:defRPr sz="950" b="1">
                 <a:solidFill>
                   <a:srgbClr val="10B981"/>
                 </a:solidFill>
@@ -7312,7 +7354,7 @@
           </a:p>
           <a:p>
             <a:pPr>
-              <a:defRPr sz="1000" b="1">
+              <a:defRPr sz="950" b="1">
                 <a:solidFill>
                   <a:srgbClr val="10B981"/>
                 </a:solidFill>
@@ -7344,14 +7386,14 @@
         </p:nvSpPr>
         <p:spPr>
           <a:xfrm>
-            <a:off x="6217920" y="1463040"/>
-            <a:ext cx="5242255" cy="4846320"/>
+            <a:off x="6217920" y="1508760"/>
+            <a:ext cx="5242255" cy="4800600"/>
           </a:xfrm>
           <a:prstGeom prst="roundRect">
             <a:avLst/>
           </a:prstGeom>
           <a:solidFill>
-            <a:srgbClr val="1E293B"/>
+            <a:srgbClr val="12192A"/>
           </a:solidFill>
           <a:ln w="15240">
             <a:solidFill>
@@ -7389,7 +7431,7 @@
         </p:nvSpPr>
         <p:spPr>
           <a:xfrm>
-            <a:off x="6400800" y="1600200"/>
+            <a:off x="6400800" y="1618488"/>
             <a:ext cx="4876495" cy="320040"/>
           </a:xfrm>
           <a:prstGeom prst="rect">
@@ -7404,14 +7446,14 @@
           <a:lstStyle/>
           <a:p>
             <a:pPr>
-              <a:defRPr sz="1050" b="1">
+              <a:defRPr sz="1000" b="1">
                 <a:solidFill>
                   <a:srgbClr val="06B6D4"/>
                 </a:solidFill>
               </a:defRPr>
             </a:pPr>
             <a:r>
-              <a:t>ENGINEERING SYSTEM SPECIFICATIONS</a:t>
+              <a:t>02. ARCHITECTURAL BILL OF MATERIALS (BOM)</a:t>
             </a:r>
           </a:p>
         </p:txBody>
@@ -7424,8 +7466,8 @@
         </p:nvSpPr>
         <p:spPr>
           <a:xfrm>
-            <a:off x="6400800" y="1920240"/>
-            <a:ext cx="4846320" cy="4206240"/>
+            <a:off x="6400800" y="1965960"/>
+            <a:ext cx="4876495" cy="4206240"/>
           </a:xfrm>
           <a:prstGeom prst="rect">
             <a:avLst/>
@@ -7439,14 +7481,14 @@
           <a:lstStyle/>
           <a:p>
             <a:pPr>
-              <a:defRPr sz="1000" b="1">
+              <a:defRPr sz="950" b="1">
                 <a:solidFill>
                   <a:srgbClr val="06B6D4"/>
                 </a:solidFill>
               </a:defRPr>
             </a:pPr>
             <a:r>
-              <a:t>Core Backend:</a:t>
+              <a:t>Core Cloud Backend:</a:t>
             </a:r>
           </a:p>
           <a:p>
@@ -7458,7 +7500,7 @@
               </a:defRPr>
             </a:pPr>
             <a:r>
-              <a:t>  FastAPI, Python 3.12, Uvicorn, SQLAlchemy 2.0, PostgreSQL / SQLite</a:t>
+              <a:t>  Python 3.12, FastAPI, Uvicorn, SQLAlchemy 2.0, PostgreSQL &amp; SQLite</a:t>
             </a:r>
           </a:p>
           <a:p>
@@ -7468,7 +7510,7 @@
           </a:p>
           <a:p>
             <a:pPr>
-              <a:defRPr sz="1000" b="1">
+              <a:defRPr sz="950" b="1">
                 <a:solidFill>
                   <a:srgbClr val="06B6D4"/>
                 </a:solidFill>
@@ -7487,7 +7529,7 @@
               </a:defRPr>
             </a:pPr>
             <a:r>
-              <a:t>  Raspberry Pi 4 (4GB) / NVIDIA Jetson Nano, RTSP IP Cabin Camera</a:t>
+              <a:t>  Raspberry Pi 4 (4GB) / NVIDIA Jetson Nano, RTSP IP Cabin Cameras</a:t>
             </a:r>
           </a:p>
           <a:p>
@@ -7497,14 +7539,14 @@
           </a:p>
           <a:p>
             <a:pPr>
-              <a:defRPr sz="1000" b="1">
+              <a:defRPr sz="950" b="1">
                 <a:solidFill>
                   <a:srgbClr val="06B6D4"/>
                 </a:solidFill>
               </a:defRPr>
             </a:pPr>
             <a:r>
-              <a:t>Computer Vision:</a:t>
+              <a:t>Computer Vision Engine:</a:t>
             </a:r>
           </a:p>
           <a:p>
@@ -7516,7 +7558,7 @@
               </a:defRPr>
             </a:pPr>
             <a:r>
-              <a:t>  OpenCV 4.9 headless, local contour background subtractor, zero cloud video</a:t>
+              <a:t>  OpenCV 4.9 headless, local contour background subtraction, zero cloud video</a:t>
             </a:r>
           </a:p>
           <a:p>
@@ -7526,14 +7568,14 @@
           </a:p>
           <a:p>
             <a:pPr>
-              <a:defRPr sz="1000" b="1">
+              <a:defRPr sz="950" b="1">
                 <a:solidFill>
                   <a:srgbClr val="06B6D4"/>
                 </a:solidFill>
               </a:defRPr>
             </a:pPr>
             <a:r>
-              <a:t>Machine Learning:</a:t>
+              <a:t>Machine Learning Models:</a:t>
             </a:r>
           </a:p>
           <a:p>
@@ -7555,14 +7597,14 @@
           </a:p>
           <a:p>
             <a:pPr>
-              <a:defRPr sz="1000" b="1">
+              <a:defRPr sz="950" b="1">
                 <a:solidFill>
                   <a:srgbClr val="06B6D4"/>
                 </a:solidFill>
               </a:defRPr>
             </a:pPr>
             <a:r>
-              <a:t>Frontend Web Radar:</a:t>
+              <a:t>Web Command Radar:</a:t>
             </a:r>
           </a:p>
           <a:p>
@@ -7584,14 +7626,14 @@
           </a:p>
           <a:p>
             <a:pPr>
-              <a:defRPr sz="1000" b="1">
+              <a:defRPr sz="950" b="1">
                 <a:solidFill>
                   <a:srgbClr val="06B6D4"/>
                 </a:solidFill>
               </a:defRPr>
             </a:pPr>
             <a:r>
-              <a:t>Mobile Passenger App:</a:t>
+              <a:t>Passenger Mobile App:</a:t>
             </a:r>
           </a:p>
           <a:p>
@@ -7613,14 +7655,14 @@
           </a:p>
           <a:p>
             <a:pPr>
-              <a:defRPr sz="1000" b="1">
+              <a:defRPr sz="950" b="1">
                 <a:solidFill>
                   <a:srgbClr val="06B6D4"/>
                 </a:solidFill>
               </a:defRPr>
             </a:pPr>
             <a:r>
-              <a:t>Deployment &amp; Telemetry:</a:t>
+              <a:t>DevOps &amp; Messaging:</a:t>
             </a:r>
           </a:p>
           <a:p>

</xml_diff>